<commit_message>
Slides: larger text on the dense pages
</commit_message>
<xml_diff>
--- a/Docs/Deliverables/Slides/Sentinel_Presentation.pptx
+++ b/Docs/Deliverables/Slides/Sentinel_Presentation.pptx
@@ -8087,7 +8087,7 @@
         <p:spPr>
           <a:xfrm>
             <a:off x="548640" y="1051560"/>
-            <a:ext cx="1691640" cy="731520"/>
+            <a:ext cx="1691640" cy="777240"/>
           </a:xfrm>
           <a:prstGeom prst="roundRect">
             <a:avLst>
@@ -8135,7 +8135,7 @@
         <p:spPr>
           <a:xfrm>
             <a:off x="548640" y="1051560"/>
-            <a:ext cx="1691640" cy="731520"/>
+            <a:ext cx="1691640" cy="777240"/>
           </a:xfrm>
           <a:prstGeom prst="rect">
             <a:avLst/>
@@ -8157,7 +8157,7 @@
               </a:spcAft>
             </a:pPr>
             <a:r>
-              <a:rPr sz="1300" b="0" i="0">
+              <a:rPr sz="1500" b="0" i="0">
                 <a:solidFill>
                   <a:srgbClr val="1E293B"/>
                 </a:solidFill>
@@ -8176,7 +8176,7 @@
               </a:spcAft>
             </a:pPr>
             <a:r>
-              <a:rPr sz="1300" b="0" i="0">
+              <a:rPr sz="1500" b="0" i="0">
                 <a:solidFill>
                   <a:srgbClr val="1E293B"/>
                 </a:solidFill>
@@ -8195,7 +8195,7 @@
         </p:nvCxnSpPr>
         <p:spPr>
           <a:xfrm>
-            <a:off x="2240280" y="1417320"/>
+            <a:off x="2240280" y="1435608"/>
             <a:ext cx="182880" cy="0"/>
           </a:xfrm>
           <a:prstGeom prst="line">
@@ -8232,7 +8232,7 @@
         <p:spPr>
           <a:xfrm>
             <a:off x="2423160" y="1051560"/>
-            <a:ext cx="1691640" cy="731520"/>
+            <a:ext cx="1691640" cy="777240"/>
           </a:xfrm>
           <a:prstGeom prst="roundRect">
             <a:avLst>
@@ -8280,7 +8280,7 @@
         <p:spPr>
           <a:xfrm>
             <a:off x="2423160" y="1051560"/>
-            <a:ext cx="1691640" cy="731520"/>
+            <a:ext cx="1691640" cy="777240"/>
           </a:xfrm>
           <a:prstGeom prst="rect">
             <a:avLst/>
@@ -8302,7 +8302,7 @@
               </a:spcAft>
             </a:pPr>
             <a:r>
-              <a:rPr sz="1300" b="0" i="0">
+              <a:rPr sz="1500" b="0" i="0">
                 <a:solidFill>
                   <a:srgbClr val="1E293B"/>
                 </a:solidFill>
@@ -8321,7 +8321,7 @@
               </a:spcAft>
             </a:pPr>
             <a:r>
-              <a:rPr sz="1300" b="0" i="0">
+              <a:rPr sz="1500" b="0" i="0">
                 <a:solidFill>
                   <a:srgbClr val="1E293B"/>
                 </a:solidFill>
@@ -8340,7 +8340,7 @@
         </p:nvCxnSpPr>
         <p:spPr>
           <a:xfrm>
-            <a:off x="4114800" y="1417320"/>
+            <a:off x="4114800" y="1435608"/>
             <a:ext cx="182880" cy="0"/>
           </a:xfrm>
           <a:prstGeom prst="line">
@@ -8377,7 +8377,7 @@
         <p:spPr>
           <a:xfrm>
             <a:off x="4297680" y="1051560"/>
-            <a:ext cx="1691640" cy="731520"/>
+            <a:ext cx="1691640" cy="777240"/>
           </a:xfrm>
           <a:prstGeom prst="roundRect">
             <a:avLst>
@@ -8425,7 +8425,7 @@
         <p:spPr>
           <a:xfrm>
             <a:off x="4297680" y="1051560"/>
-            <a:ext cx="1691640" cy="731520"/>
+            <a:ext cx="1691640" cy="777240"/>
           </a:xfrm>
           <a:prstGeom prst="rect">
             <a:avLst/>
@@ -8447,7 +8447,7 @@
               </a:spcAft>
             </a:pPr>
             <a:r>
-              <a:rPr sz="1300" b="0" i="0">
+              <a:rPr sz="1500" b="0" i="0">
                 <a:solidFill>
                   <a:srgbClr val="1E293B"/>
                 </a:solidFill>
@@ -8466,7 +8466,7 @@
               </a:spcAft>
             </a:pPr>
             <a:r>
-              <a:rPr sz="1300" b="0" i="0">
+              <a:rPr sz="1500" b="0" i="0">
                 <a:solidFill>
                   <a:srgbClr val="1E293B"/>
                 </a:solidFill>
@@ -8485,7 +8485,7 @@
         </p:nvCxnSpPr>
         <p:spPr>
           <a:xfrm>
-            <a:off x="5989320" y="1417320"/>
+            <a:off x="5989320" y="1435608"/>
             <a:ext cx="182880" cy="0"/>
           </a:xfrm>
           <a:prstGeom prst="line">
@@ -8522,7 +8522,7 @@
         <p:spPr>
           <a:xfrm>
             <a:off x="6172200" y="1051560"/>
-            <a:ext cx="1691640" cy="731520"/>
+            <a:ext cx="1691640" cy="777240"/>
           </a:xfrm>
           <a:prstGeom prst="roundRect">
             <a:avLst>
@@ -8570,7 +8570,7 @@
         <p:spPr>
           <a:xfrm>
             <a:off x="6172200" y="1051560"/>
-            <a:ext cx="1691640" cy="731520"/>
+            <a:ext cx="1691640" cy="777240"/>
           </a:xfrm>
           <a:prstGeom prst="rect">
             <a:avLst/>
@@ -8592,7 +8592,7 @@
               </a:spcAft>
             </a:pPr>
             <a:r>
-              <a:rPr sz="1300" b="0" i="0">
+              <a:rPr sz="1500" b="0" i="0">
                 <a:solidFill>
                   <a:srgbClr val="1E293B"/>
                 </a:solidFill>
@@ -8611,7 +8611,7 @@
               </a:spcAft>
             </a:pPr>
             <a:r>
-              <a:rPr sz="1300" b="0" i="0">
+              <a:rPr sz="1500" b="0" i="0">
                 <a:solidFill>
                   <a:srgbClr val="1E293B"/>
                 </a:solidFill>
@@ -8630,7 +8630,7 @@
         </p:nvCxnSpPr>
         <p:spPr>
           <a:xfrm>
-            <a:off x="7863840" y="1417320"/>
+            <a:off x="7863840" y="1435608"/>
             <a:ext cx="182880" cy="0"/>
           </a:xfrm>
           <a:prstGeom prst="line">
@@ -8667,7 +8667,7 @@
         <p:spPr>
           <a:xfrm>
             <a:off x="8046720" y="1051560"/>
-            <a:ext cx="1691640" cy="731520"/>
+            <a:ext cx="1691640" cy="777240"/>
           </a:xfrm>
           <a:prstGeom prst="roundRect">
             <a:avLst>
@@ -8715,7 +8715,7 @@
         <p:spPr>
           <a:xfrm>
             <a:off x="8046720" y="1051560"/>
-            <a:ext cx="1691640" cy="731520"/>
+            <a:ext cx="1691640" cy="777240"/>
           </a:xfrm>
           <a:prstGeom prst="rect">
             <a:avLst/>
@@ -8737,7 +8737,7 @@
               </a:spcAft>
             </a:pPr>
             <a:r>
-              <a:rPr sz="1300" b="0" i="0">
+              <a:rPr sz="1500" b="0" i="0">
                 <a:solidFill>
                   <a:srgbClr val="1E293B"/>
                 </a:solidFill>
@@ -8756,7 +8756,7 @@
               </a:spcAft>
             </a:pPr>
             <a:r>
-              <a:rPr sz="1300" b="0" i="0">
+              <a:rPr sz="1500" b="0" i="0">
                 <a:solidFill>
                   <a:srgbClr val="1E293B"/>
                 </a:solidFill>
@@ -8775,7 +8775,7 @@
         </p:nvCxnSpPr>
         <p:spPr>
           <a:xfrm>
-            <a:off x="9738360" y="1417320"/>
+            <a:off x="9738360" y="1435608"/>
             <a:ext cx="182880" cy="0"/>
           </a:xfrm>
           <a:prstGeom prst="line">
@@ -8812,7 +8812,7 @@
         <p:spPr>
           <a:xfrm>
             <a:off x="9921240" y="1051560"/>
-            <a:ext cx="1691640" cy="731520"/>
+            <a:ext cx="1691640" cy="777240"/>
           </a:xfrm>
           <a:prstGeom prst="roundRect">
             <a:avLst>
@@ -8860,7 +8860,7 @@
         <p:spPr>
           <a:xfrm>
             <a:off x="9921240" y="1051560"/>
-            <a:ext cx="1691640" cy="731520"/>
+            <a:ext cx="1691640" cy="777240"/>
           </a:xfrm>
           <a:prstGeom prst="rect">
             <a:avLst/>
@@ -8882,7 +8882,7 @@
               </a:spcAft>
             </a:pPr>
             <a:r>
-              <a:rPr sz="1300" b="0" i="0">
+              <a:rPr sz="1500" b="0" i="0">
                 <a:solidFill>
                   <a:srgbClr val="1E293B"/>
                 </a:solidFill>
@@ -8901,7 +8901,7 @@
               </a:spcAft>
             </a:pPr>
             <a:r>
-              <a:rPr sz="1300" b="0" i="0">
+              <a:rPr sz="1500" b="0" i="0">
                 <a:solidFill>
                   <a:srgbClr val="1E293B"/>
                 </a:solidFill>
@@ -8920,8 +8920,8 @@
         </p:nvSpPr>
         <p:spPr>
           <a:xfrm>
-            <a:off x="548640" y="2011680"/>
-            <a:ext cx="5760720" cy="1965960"/>
+            <a:off x="548640" y="2057400"/>
+            <a:ext cx="5669280" cy="2240280"/>
           </a:xfrm>
           <a:prstGeom prst="roundRect">
             <a:avLst>
@@ -8968,8 +8968,8 @@
         </p:nvSpPr>
         <p:spPr>
           <a:xfrm>
-            <a:off x="685800" y="2048256"/>
-            <a:ext cx="5486400" cy="320040"/>
+            <a:off x="685800" y="2103120"/>
+            <a:ext cx="5394960" cy="365760"/>
           </a:xfrm>
           <a:prstGeom prst="rect">
             <a:avLst/>
@@ -8991,7 +8991,7 @@
               </a:spcAft>
             </a:pPr>
             <a:r>
-              <a:rPr sz="1400" b="1" i="0">
+              <a:rPr sz="1700" b="1" i="0">
                 <a:solidFill>
                   <a:srgbClr val="0F8F85"/>
                 </a:solidFill>
@@ -9018,7 +9018,7 @@
         </p:blipFill>
         <p:spPr>
           <a:xfrm>
-            <a:off x="731520" y="2423160"/>
+            <a:off x="731520" y="2542032"/>
             <a:ext cx="5303520" cy="442486"/>
           </a:xfrm>
           <a:prstGeom prst="rect">
@@ -9034,8 +9034,8 @@
         </p:nvSpPr>
         <p:spPr>
           <a:xfrm>
-            <a:off x="685800" y="2880360"/>
-            <a:ext cx="5486400" cy="1097280"/>
+            <a:off x="685800" y="3017520"/>
+            <a:ext cx="5394960" cy="1280160"/>
           </a:xfrm>
           <a:prstGeom prst="rect">
             <a:avLst/>
@@ -9053,17 +9053,17 @@
                 <a:spcPct val="100000"/>
               </a:lnSpc>
               <a:spcAft>
-                <a:spcPts val="300"/>
-              </a:spcAft>
-            </a:pPr>
-            <a:r>
-              <a:rPr sz="1400" b="0" i="0">
+                <a:spcPts val="400"/>
+              </a:spcAft>
+            </a:pPr>
+            <a:r>
+              <a:rPr sz="1600" b="0" i="0">
                 <a:solidFill>
                   <a:srgbClr val="1E293B"/>
                 </a:solidFill>
                 <a:latin typeface="Calibri"/>
               </a:rPr>
-              <a:t>Matrices act right to left, so the brick is stretched, turned about its own centre, and carried last.</a:t>
+              <a:t>Matrices act right to left: the brick is stretched, turned about its own centre, and moved last.</a:t>
             </a:r>
           </a:p>
           <a:p>
@@ -9072,17 +9072,17 @@
                 <a:spcPct val="100000"/>
               </a:lnSpc>
               <a:spcAft>
-                <a:spcPts val="300"/>
-              </a:spcAft>
-            </a:pPr>
-            <a:r>
-              <a:rPr sz="1400" b="0" i="0">
+                <a:spcPts val="400"/>
+              </a:spcAft>
+            </a:pPr>
+            <a:r>
+              <a:rPr sz="1600" b="0" i="0">
                 <a:solidFill>
                   <a:srgbClr val="1E293B"/>
                 </a:solidFill>
                 <a:latin typeface="Calibri"/>
               </a:rPr>
-              <a:t>Example: (1,0,0) → S(2,1,1) → R_y 90° → T(5,0,0) = (5, 0, −2)</a:t>
+              <a:t>(1,0,0) → S(2,1,1) → R_y 90° → T(5,0,0) = (5, 0, −2)</a:t>
             </a:r>
           </a:p>
         </p:txBody>
@@ -9095,8 +9095,8 @@
         </p:nvSpPr>
         <p:spPr>
           <a:xfrm>
-            <a:off x="548640" y="4114800"/>
-            <a:ext cx="5760720" cy="2240280"/>
+            <a:off x="548640" y="4434840"/>
+            <a:ext cx="5669280" cy="1920240"/>
           </a:xfrm>
           <a:prstGeom prst="roundRect">
             <a:avLst>
@@ -9143,8 +9143,8 @@
         </p:nvSpPr>
         <p:spPr>
           <a:xfrm>
-            <a:off x="685800" y="4151376"/>
-            <a:ext cx="5486400" cy="320040"/>
+            <a:off x="685800" y="4480560"/>
+            <a:ext cx="5394960" cy="365760"/>
           </a:xfrm>
           <a:prstGeom prst="rect">
             <a:avLst/>
@@ -9166,7 +9166,7 @@
               </a:spcAft>
             </a:pPr>
             <a:r>
-              <a:rPr sz="1400" b="1" i="0">
+              <a:rPr sz="1700" b="1" i="0">
                 <a:solidFill>
                   <a:srgbClr val="0F8F85"/>
                 </a:solidFill>
@@ -9193,8 +9193,8 @@
         </p:blipFill>
         <p:spPr>
           <a:xfrm>
-            <a:off x="822960" y="4526280"/>
-            <a:ext cx="1963826" cy="777240"/>
+            <a:off x="777240" y="4892040"/>
+            <a:ext cx="2079345" cy="822960"/>
           </a:xfrm>
           <a:prstGeom prst="rect">
             <a:avLst/>
@@ -9209,8 +9209,8 @@
         </p:nvSpPr>
         <p:spPr>
           <a:xfrm>
-            <a:off x="2834640" y="4526280"/>
-            <a:ext cx="3383280" cy="1005840"/>
+            <a:off x="2926080" y="4937760"/>
+            <a:ext cx="3200400" cy="822960"/>
           </a:xfrm>
           <a:prstGeom prst="rect">
             <a:avLst/>
@@ -9232,13 +9232,13 @@
               </a:spcAft>
             </a:pPr>
             <a:r>
-              <a:rPr sz="1400" b="0" i="0">
+              <a:rPr sz="1600" b="0" i="0">
                 <a:solidFill>
                   <a:srgbClr val="1E293B"/>
                 </a:solidFill>
                 <a:latin typeface="Calibri"/>
               </a:rPr>
-              <a:t>Keeps normals perpendicular after a stretch</a:t>
+              <a:t>stays perpendicular after a stretch</a:t>
             </a:r>
           </a:p>
         </p:txBody>
@@ -9251,8 +9251,8 @@
         </p:nvSpPr>
         <p:spPr>
           <a:xfrm>
-            <a:off x="685800" y="5440680"/>
-            <a:ext cx="5486400" cy="868680"/>
+            <a:off x="685800" y="5760720"/>
+            <a:ext cx="5394960" cy="548640"/>
           </a:xfrm>
           <a:prstGeom prst="rect">
             <a:avLst/>
@@ -9274,127 +9274,27 @@
               </a:spcAft>
             </a:pPr>
             <a:r>
-              <a:rPr sz="1300" b="0" i="0">
+              <a:rPr sz="1500" b="0" i="0">
                 <a:solidFill>
                   <a:srgbClr val="64748B"/>
                 </a:solidFill>
                 <a:latin typeface="Calibri"/>
               </a:rPr>
-              <a:t>S = diag(2,1,1), n = (1,1,0)/√2: correct (0.447, 0.894, 0), naive (0.894, 0.447, 0) is wrong; det &lt; 0 flips winding</a:t>
-            </a:r>
-          </a:p>
-        </p:txBody>
-      </p:sp>
-      <p:pic>
-        <p:nvPicPr>
-          <p:cNvPr id="34" name="Picture 33" descr="tank.jpg"/>
-          <p:cNvPicPr>
-            <a:picLocks noChangeAspect="1"/>
-          </p:cNvPicPr>
-          <p:nvPr/>
-        </p:nvPicPr>
-        <p:blipFill>
-          <a:blip r:embed="rId6"/>
-          <a:stretch>
-            <a:fillRect/>
-          </a:stretch>
-        </p:blipFill>
-        <p:spPr>
-          <a:xfrm>
-            <a:off x="6583680" y="2011680"/>
-            <a:ext cx="2468880" cy="1388745"/>
-          </a:xfrm>
-          <a:prstGeom prst="rect">
-            <a:avLst/>
-          </a:prstGeom>
-          <a:ln w="9525">
-            <a:solidFill>
-              <a:srgbClr val="D5DEE8"/>
-            </a:solidFill>
-          </a:ln>
-        </p:spPr>
-      </p:pic>
-      <p:pic>
-        <p:nvPicPr>
-          <p:cNvPr id="35" name="Picture 34" descr="truck.jpg"/>
-          <p:cNvPicPr>
-            <a:picLocks noChangeAspect="1"/>
-          </p:cNvPicPr>
-          <p:nvPr/>
-        </p:nvPicPr>
-        <p:blipFill>
-          <a:blip r:embed="rId7"/>
-          <a:stretch>
-            <a:fillRect/>
-          </a:stretch>
-        </p:blipFill>
-        <p:spPr>
-          <a:xfrm>
-            <a:off x="9235440" y="2011680"/>
-            <a:ext cx="2468880" cy="1388745"/>
-          </a:xfrm>
-          <a:prstGeom prst="rect">
-            <a:avLst/>
-          </a:prstGeom>
-          <a:ln w="9525">
-            <a:solidFill>
-              <a:srgbClr val="D5DEE8"/>
-            </a:solidFill>
-          </a:ln>
-        </p:spPr>
-      </p:pic>
-      <p:sp>
-        <p:nvSpPr>
-          <p:cNvPr id="36" name="TextBox 35"/>
-          <p:cNvSpPr txBox="1"/>
-          <p:nvPr/>
-        </p:nvSpPr>
-        <p:spPr>
-          <a:xfrm>
-            <a:off x="6583680" y="3437001"/>
-            <a:ext cx="5120640" cy="320040"/>
-          </a:xfrm>
-          <a:prstGeom prst="rect">
-            <a:avLst/>
-          </a:prstGeom>
-          <a:noFill/>
-        </p:spPr>
-        <p:txBody>
-          <a:bodyPr wrap="square" lIns="36576" rIns="36576" tIns="18288" bIns="18288" anchor="t">
-            <a:spAutoFit/>
-          </a:bodyPr>
-          <a:lstStyle/>
-          <a:p>
-            <a:pPr algn="ctr">
-              <a:lnSpc>
-                <a:spcPct val="100000"/>
-              </a:lnSpc>
-              <a:spcAft>
-                <a:spcPts val="400"/>
-              </a:spcAft>
-            </a:pPr>
-            <a:r>
-              <a:rPr sz="1300" b="0" i="1">
-                <a:solidFill>
-                  <a:srgbClr val="64748B"/>
-                </a:solidFill>
-                <a:latin typeface="Calibri"/>
-              </a:rPr>
-              <a:t>Tank (hull, turret, gun) and truck: transformed primitives</a:t>
-            </a:r>
-          </a:p>
-        </p:txBody>
-      </p:sp>
-      <p:sp>
-        <p:nvSpPr>
-          <p:cNvPr id="37" name="Rounded Rectangle 36"/>
+              <a:t>S = diag(2,1,1): correct (0.447, 0.894, 0); naive (0.894, 0.447, 0) is wrong</a:t>
+            </a:r>
+          </a:p>
+        </p:txBody>
+      </p:sp>
+      <p:sp>
+        <p:nvSpPr>
+          <p:cNvPr id="34" name="Rounded Rectangle 33"/>
           <p:cNvSpPr/>
           <p:nvPr/>
         </p:nvSpPr>
         <p:spPr>
           <a:xfrm>
-            <a:off x="6583680" y="3429000"/>
-            <a:ext cx="5120640" cy="2926080"/>
+            <a:off x="6492240" y="2057400"/>
+            <a:ext cx="5212080" cy="1600200"/>
           </a:xfrm>
           <a:prstGeom prst="roundRect">
             <a:avLst>
@@ -9435,14 +9335,14 @@
       </p:sp>
       <p:sp>
         <p:nvSpPr>
-          <p:cNvPr id="38" name="TextBox 37"/>
+          <p:cNvPr id="35" name="TextBox 34"/>
           <p:cNvSpPr txBox="1"/>
           <p:nvPr/>
         </p:nvSpPr>
         <p:spPr>
           <a:xfrm>
-            <a:off x="6720840" y="3465576"/>
-            <a:ext cx="4846320" cy="320040"/>
+            <a:off x="6629400" y="2103120"/>
+            <a:ext cx="4937760" cy="365760"/>
           </a:xfrm>
           <a:prstGeom prst="rect">
             <a:avLst/>
@@ -9464,7 +9364,121 @@
               </a:spcAft>
             </a:pPr>
             <a:r>
-              <a:rPr sz="1400" b="1" i="0">
+              <a:rPr sz="1700" b="1" i="0">
+                <a:solidFill>
+                  <a:srgbClr val="0F8F85"/>
+                </a:solidFill>
+                <a:latin typeface="Calibri"/>
+              </a:rPr>
+              <a:t>Rotation about y</a:t>
+            </a:r>
+          </a:p>
+        </p:txBody>
+      </p:sp>
+      <p:pic>
+        <p:nvPicPr>
+          <p:cNvPr id="36" name="Picture 35" descr="ry.png"/>
+          <p:cNvPicPr>
+            <a:picLocks noChangeAspect="1"/>
+          </p:cNvPicPr>
+          <p:nvPr/>
+        </p:nvPicPr>
+        <p:blipFill>
+          <a:blip r:embed="rId6"/>
+          <a:stretch>
+            <a:fillRect/>
+          </a:stretch>
+        </p:blipFill>
+        <p:spPr>
+          <a:xfrm>
+            <a:off x="6949440" y="2514600"/>
+            <a:ext cx="3375251" cy="1051560"/>
+          </a:xfrm>
+          <a:prstGeom prst="rect">
+            <a:avLst/>
+          </a:prstGeom>
+        </p:spPr>
+      </p:pic>
+      <p:sp>
+        <p:nvSpPr>
+          <p:cNvPr id="37" name="Rounded Rectangle 36"/>
+          <p:cNvSpPr/>
+          <p:nvPr/>
+        </p:nvSpPr>
+        <p:spPr>
+          <a:xfrm>
+            <a:off x="6492240" y="3794760"/>
+            <a:ext cx="5212080" cy="1325880"/>
+          </a:xfrm>
+          <a:prstGeom prst="roundRect">
+            <a:avLst>
+              <a:gd name="adj" fmla="val 6000"/>
+            </a:avLst>
+          </a:prstGeom>
+          <a:solidFill>
+            <a:srgbClr val="FFFFFF"/>
+          </a:solidFill>
+          <a:ln w="9525">
+            <a:solidFill>
+              <a:srgbClr val="D5DEE8"/>
+            </a:solidFill>
+          </a:ln>
+          <a:effectLst/>
+        </p:spPr>
+        <p:style>
+          <a:lnRef idx="1">
+            <a:schemeClr val="accent1"/>
+          </a:lnRef>
+          <a:fillRef idx="3">
+            <a:schemeClr val="accent1"/>
+          </a:fillRef>
+          <a:effectRef idx="2">
+            <a:schemeClr val="accent1"/>
+          </a:effectRef>
+          <a:fontRef idx="minor">
+            <a:schemeClr val="lt1"/>
+          </a:fontRef>
+        </p:style>
+        <p:txBody>
+          <a:bodyPr rtlCol="0" anchor="ctr"/>
+          <a:lstStyle/>
+          <a:p>
+            <a:pPr algn="ctr"/>
+          </a:p>
+        </p:txBody>
+      </p:sp>
+      <p:sp>
+        <p:nvSpPr>
+          <p:cNvPr id="38" name="TextBox 37"/>
+          <p:cNvSpPr txBox="1"/>
+          <p:nvPr/>
+        </p:nvSpPr>
+        <p:spPr>
+          <a:xfrm>
+            <a:off x="6629400" y="3840480"/>
+            <a:ext cx="4937760" cy="365760"/>
+          </a:xfrm>
+          <a:prstGeom prst="rect">
+            <a:avLst/>
+          </a:prstGeom>
+          <a:noFill/>
+        </p:spPr>
+        <p:txBody>
+          <a:bodyPr wrap="square" lIns="36576" rIns="36576" tIns="18288" bIns="18288" anchor="t">
+            <a:spAutoFit/>
+          </a:bodyPr>
+          <a:lstStyle/>
+          <a:p>
+            <a:pPr algn="l">
+              <a:lnSpc>
+                <a:spcPct val="100000"/>
+              </a:lnSpc>
+              <a:spcAft>
+                <a:spcPts val="400"/>
+              </a:spcAft>
+            </a:pPr>
+            <a:r>
+              <a:rPr sz="1700" b="1" i="0">
                 <a:solidFill>
                   <a:srgbClr val="0F8F85"/>
                 </a:solidFill>
@@ -9478,6 +9492,162 @@
       <p:pic>
         <p:nvPicPr>
           <p:cNvPr id="39" name="Picture 38" descr="mgun.png"/>
+          <p:cNvPicPr>
+            <a:picLocks noChangeAspect="1"/>
+          </p:cNvPicPr>
+          <p:nvPr/>
+        </p:nvPicPr>
+        <p:blipFill>
+          <a:blip r:embed="rId7"/>
+          <a:stretch>
+            <a:fillRect/>
+          </a:stretch>
+        </p:blipFill>
+        <p:spPr>
+          <a:xfrm>
+            <a:off x="6629400" y="4297680"/>
+            <a:ext cx="4937760" cy="369671"/>
+          </a:xfrm>
+          <a:prstGeom prst="rect">
+            <a:avLst/>
+          </a:prstGeom>
+        </p:spPr>
+      </p:pic>
+      <p:sp>
+        <p:nvSpPr>
+          <p:cNvPr id="40" name="TextBox 39"/>
+          <p:cNvSpPr txBox="1"/>
+          <p:nvPr/>
+        </p:nvSpPr>
+        <p:spPr>
+          <a:xfrm>
+            <a:off x="6629400" y="4663440"/>
+            <a:ext cx="4937760" cy="457200"/>
+          </a:xfrm>
+          <a:prstGeom prst="rect">
+            <a:avLst/>
+          </a:prstGeom>
+          <a:noFill/>
+        </p:spPr>
+        <p:txBody>
+          <a:bodyPr wrap="square" lIns="36576" rIns="36576" tIns="18288" bIns="18288" anchor="t">
+            <a:spAutoFit/>
+          </a:bodyPr>
+          <a:lstStyle/>
+          <a:p>
+            <a:pPr algn="l">
+              <a:lnSpc>
+                <a:spcPct val="100000"/>
+              </a:lnSpc>
+              <a:spcAft>
+                <a:spcPts val="400"/>
+              </a:spcAft>
+            </a:pPr>
+            <a:r>
+              <a:rPr sz="1500" b="0" i="0">
+                <a:solidFill>
+                  <a:srgbClr val="64748B"/>
+                </a:solidFill>
+                <a:latin typeface="Calibri"/>
+              </a:rPr>
+              <a:t>Turning the hull carries turret and gun</a:t>
+            </a:r>
+          </a:p>
+        </p:txBody>
+      </p:sp>
+      <p:sp>
+        <p:nvSpPr>
+          <p:cNvPr id="41" name="Rounded Rectangle 40"/>
+          <p:cNvSpPr/>
+          <p:nvPr/>
+        </p:nvSpPr>
+        <p:spPr>
+          <a:xfrm>
+            <a:off x="6492240" y="5257800"/>
+            <a:ext cx="5212080" cy="1097280"/>
+          </a:xfrm>
+          <a:prstGeom prst="roundRect">
+            <a:avLst>
+              <a:gd name="adj" fmla="val 6000"/>
+            </a:avLst>
+          </a:prstGeom>
+          <a:solidFill>
+            <a:srgbClr val="FFFFFF"/>
+          </a:solidFill>
+          <a:ln w="9525">
+            <a:solidFill>
+              <a:srgbClr val="D5DEE8"/>
+            </a:solidFill>
+          </a:ln>
+          <a:effectLst/>
+        </p:spPr>
+        <p:style>
+          <a:lnRef idx="1">
+            <a:schemeClr val="accent1"/>
+          </a:lnRef>
+          <a:fillRef idx="3">
+            <a:schemeClr val="accent1"/>
+          </a:fillRef>
+          <a:effectRef idx="2">
+            <a:schemeClr val="accent1"/>
+          </a:effectRef>
+          <a:fontRef idx="minor">
+            <a:schemeClr val="lt1"/>
+          </a:fontRef>
+        </p:style>
+        <p:txBody>
+          <a:bodyPr rtlCol="0" anchor="ctr"/>
+          <a:lstStyle/>
+          <a:p>
+            <a:pPr algn="ctr"/>
+          </a:p>
+        </p:txBody>
+      </p:sp>
+      <p:sp>
+        <p:nvSpPr>
+          <p:cNvPr id="42" name="TextBox 41"/>
+          <p:cNvSpPr txBox="1"/>
+          <p:nvPr/>
+        </p:nvSpPr>
+        <p:spPr>
+          <a:xfrm>
+            <a:off x="6629400" y="5303520"/>
+            <a:ext cx="4937760" cy="365760"/>
+          </a:xfrm>
+          <a:prstGeom prst="rect">
+            <a:avLst/>
+          </a:prstGeom>
+          <a:noFill/>
+        </p:spPr>
+        <p:txBody>
+          <a:bodyPr wrap="square" lIns="36576" rIns="36576" tIns="18288" bIns="18288" anchor="t">
+            <a:spAutoFit/>
+          </a:bodyPr>
+          <a:lstStyle/>
+          <a:p>
+            <a:pPr algn="l">
+              <a:lnSpc>
+                <a:spcPct val="100000"/>
+              </a:lnSpc>
+              <a:spcAft>
+                <a:spcPts val="400"/>
+              </a:spcAft>
+            </a:pPr>
+            <a:r>
+              <a:rPr sz="1700" b="1" i="0">
+                <a:solidFill>
+                  <a:srgbClr val="0F8F85"/>
+                </a:solidFill>
+                <a:latin typeface="Calibri"/>
+              </a:rPr>
+              <a:t>World to screen</a:t>
+            </a:r>
+          </a:p>
+        </p:txBody>
+      </p:sp>
+      <p:pic>
+        <p:nvPicPr>
+          <p:cNvPr id="43" name="Picture 42" descr="clip.png"/>
           <p:cNvPicPr>
             <a:picLocks noChangeAspect="1"/>
           </p:cNvPicPr>
@@ -9491,164 +9661,14 @@
         </p:blipFill>
         <p:spPr>
           <a:xfrm>
-            <a:off x="6766560" y="3840480"/>
-            <a:ext cx="4754880" cy="355980"/>
+            <a:off x="6675120" y="5760720"/>
+            <a:ext cx="4206240" cy="495286"/>
           </a:xfrm>
           <a:prstGeom prst="rect">
             <a:avLst/>
           </a:prstGeom>
         </p:spPr>
       </p:pic>
-      <p:sp>
-        <p:nvSpPr>
-          <p:cNvPr id="40" name="TextBox 39"/>
-          <p:cNvSpPr txBox="1"/>
-          <p:nvPr/>
-        </p:nvSpPr>
-        <p:spPr>
-          <a:xfrm>
-            <a:off x="6720840" y="4297680"/>
-            <a:ext cx="4846320" cy="822960"/>
-          </a:xfrm>
-          <a:prstGeom prst="rect">
-            <a:avLst/>
-          </a:prstGeom>
-          <a:noFill/>
-        </p:spPr>
-        <p:txBody>
-          <a:bodyPr wrap="square" lIns="36576" rIns="36576" tIns="18288" bIns="18288" anchor="t">
-            <a:spAutoFit/>
-          </a:bodyPr>
-          <a:lstStyle/>
-          <a:p>
-            <a:pPr algn="l">
-              <a:lnSpc>
-                <a:spcPct val="100000"/>
-              </a:lnSpc>
-              <a:spcAft>
-                <a:spcPts val="200"/>
-              </a:spcAft>
-            </a:pPr>
-            <a:r>
-              <a:rPr sz="1400" b="0" i="0">
-                <a:solidFill>
-                  <a:srgbClr val="1E293B"/>
-                </a:solidFill>
-                <a:latin typeface="Calibri"/>
-              </a:rPr>
-              <a:t>The turret and gun inherit the hull matrix: turning the hull carries them along.</a:t>
-            </a:r>
-          </a:p>
-        </p:txBody>
-      </p:sp>
-      <p:sp>
-        <p:nvSpPr>
-          <p:cNvPr id="41" name="TextBox 40"/>
-          <p:cNvSpPr txBox="1"/>
-          <p:nvPr/>
-        </p:nvSpPr>
-        <p:spPr>
-          <a:xfrm>
-            <a:off x="6720840" y="5074920"/>
-            <a:ext cx="4846320" cy="320040"/>
-          </a:xfrm>
-          <a:prstGeom prst="rect">
-            <a:avLst/>
-          </a:prstGeom>
-          <a:noFill/>
-        </p:spPr>
-        <p:txBody>
-          <a:bodyPr wrap="square" lIns="36576" rIns="36576" tIns="18288" bIns="18288" anchor="t">
-            <a:spAutoFit/>
-          </a:bodyPr>
-          <a:lstStyle/>
-          <a:p>
-            <a:pPr algn="l">
-              <a:lnSpc>
-                <a:spcPct val="100000"/>
-              </a:lnSpc>
-              <a:spcAft>
-                <a:spcPts val="400"/>
-              </a:spcAft>
-            </a:pPr>
-            <a:r>
-              <a:rPr sz="1400" b="1" i="0">
-                <a:solidFill>
-                  <a:srgbClr val="0F8F85"/>
-                </a:solidFill>
-                <a:latin typeface="Calibri"/>
-              </a:rPr>
-              <a:t>World to screen</a:t>
-            </a:r>
-          </a:p>
-        </p:txBody>
-      </p:sp>
-      <p:pic>
-        <p:nvPicPr>
-          <p:cNvPr id="42" name="Picture 41" descr="clip.png"/>
-          <p:cNvPicPr>
-            <a:picLocks noChangeAspect="1"/>
-          </p:cNvPicPr>
-          <p:nvPr/>
-        </p:nvPicPr>
-        <p:blipFill>
-          <a:blip r:embed="rId9"/>
-          <a:stretch>
-            <a:fillRect/>
-          </a:stretch>
-        </p:blipFill>
-        <p:spPr>
-          <a:xfrm>
-            <a:off x="6766560" y="5440680"/>
-            <a:ext cx="4023360" cy="473752"/>
-          </a:xfrm>
-          <a:prstGeom prst="rect">
-            <a:avLst/>
-          </a:prstGeom>
-        </p:spPr>
-      </p:pic>
-      <p:sp>
-        <p:nvSpPr>
-          <p:cNvPr id="43" name="TextBox 42"/>
-          <p:cNvSpPr txBox="1"/>
-          <p:nvPr/>
-        </p:nvSpPr>
-        <p:spPr>
-          <a:xfrm>
-            <a:off x="6720840" y="5897880"/>
-            <a:ext cx="4846320" cy="411480"/>
-          </a:xfrm>
-          <a:prstGeom prst="rect">
-            <a:avLst/>
-          </a:prstGeom>
-          <a:noFill/>
-        </p:spPr>
-        <p:txBody>
-          <a:bodyPr wrap="square" lIns="36576" rIns="36576" tIns="18288" bIns="18288" anchor="t">
-            <a:spAutoFit/>
-          </a:bodyPr>
-          <a:lstStyle/>
-          <a:p>
-            <a:pPr algn="l">
-              <a:lnSpc>
-                <a:spcPct val="100000"/>
-              </a:lnSpc>
-              <a:spcAft>
-                <a:spcPts val="400"/>
-              </a:spcAft>
-            </a:pPr>
-            <a:r>
-              <a:rPr sz="1300" b="0" i="0">
-                <a:solidFill>
-                  <a:srgbClr val="64748B"/>
-                </a:solidFill>
-                <a:latin typeface="Calibri"/>
-              </a:rPr>
-              <a:t>view V (look-at), projection P divides by depth</a:t>
-            </a:r>
-          </a:p>
-        </p:txBody>
-      </p:sp>
     </p:spTree>
   </p:cSld>
   <p:clrMapOvr>
@@ -9903,8 +9923,8 @@
         </p:blipFill>
         <p:spPr>
           <a:xfrm>
-            <a:off x="548640" y="1024128"/>
-            <a:ext cx="7589520" cy="769872"/>
+            <a:off x="548640" y="1051560"/>
+            <a:ext cx="8412480" cy="853352"/>
           </a:xfrm>
           <a:prstGeom prst="rect">
             <a:avLst/>
@@ -9919,8 +9939,8 @@
         </p:nvSpPr>
         <p:spPr>
           <a:xfrm>
-            <a:off x="8275320" y="1005840"/>
-            <a:ext cx="3474720" cy="502920"/>
+            <a:off x="9418320" y="1024128"/>
+            <a:ext cx="2377440" cy="731520"/>
           </a:xfrm>
           <a:prstGeom prst="rect">
             <a:avLst/>
@@ -9942,13 +9962,13 @@
               </a:spcAft>
             </a:pPr>
             <a:r>
-              <a:rPr sz="1200" b="0" i="1">
+              <a:rPr sz="1300" b="0" i="1">
                 <a:solidFill>
                   <a:srgbClr val="64748B"/>
                 </a:solidFill>
                 <a:latin typeface="Calibri"/>
               </a:rPr>
-              <a:t>f = illumination model, att = falloff, sh = shadow</a:t>
+              <a:t>f = model, att = falloff, sh = shadow</a:t>
             </a:r>
           </a:p>
         </p:txBody>
@@ -9961,8 +9981,8 @@
         </p:nvSpPr>
         <p:spPr>
           <a:xfrm>
-            <a:off x="548640" y="1645920"/>
-            <a:ext cx="5760720" cy="4709160"/>
+            <a:off x="548640" y="1783080"/>
+            <a:ext cx="6400800" cy="4572000"/>
           </a:xfrm>
           <a:prstGeom prst="roundRect">
             <a:avLst>
@@ -10009,8 +10029,8 @@
         </p:nvSpPr>
         <p:spPr>
           <a:xfrm>
-            <a:off x="685800" y="1773936"/>
-            <a:ext cx="1691640" cy="457200"/>
+            <a:off x="685800" y="1929384"/>
+            <a:ext cx="1920240" cy="502920"/>
           </a:xfrm>
           <a:prstGeom prst="rect">
             <a:avLst/>
@@ -10032,7 +10052,7 @@
               </a:spcAft>
             </a:pPr>
             <a:r>
-              <a:rPr sz="1400" b="1" i="0">
+              <a:rPr sz="1600" b="1" i="0">
                 <a:solidFill>
                   <a:srgbClr val="0F8F85"/>
                 </a:solidFill>
@@ -10059,8 +10079,8 @@
         </p:blipFill>
         <p:spPr>
           <a:xfrm>
-            <a:off x="2468880" y="1755648"/>
-            <a:ext cx="687787" cy="457199"/>
+            <a:off x="2651760" y="1892807"/>
+            <a:ext cx="852856" cy="566928"/>
           </a:xfrm>
           <a:prstGeom prst="rect">
             <a:avLst/>
@@ -10075,8 +10095,8 @@
         </p:nvSpPr>
         <p:spPr>
           <a:xfrm>
-            <a:off x="685800" y="2505456"/>
-            <a:ext cx="1691640" cy="457200"/>
+            <a:off x="685800" y="2670048"/>
+            <a:ext cx="1920240" cy="502920"/>
           </a:xfrm>
           <a:prstGeom prst="rect">
             <a:avLst/>
@@ -10098,7 +10118,7 @@
               </a:spcAft>
             </a:pPr>
             <a:r>
-              <a:rPr sz="1400" b="1" i="0">
+              <a:rPr sz="1600" b="1" i="0">
                 <a:solidFill>
                   <a:srgbClr val="0F8F85"/>
                 </a:solidFill>
@@ -10125,8 +10145,8 @@
         </p:blipFill>
         <p:spPr>
           <a:xfrm>
-            <a:off x="2468880" y="2487168"/>
-            <a:ext cx="2821172" cy="457200"/>
+            <a:off x="2651760" y="2633472"/>
+            <a:ext cx="3272559" cy="530352"/>
           </a:xfrm>
           <a:prstGeom prst="rect">
             <a:avLst/>
@@ -10141,8 +10161,8 @@
         </p:nvSpPr>
         <p:spPr>
           <a:xfrm>
-            <a:off x="685800" y="3236976"/>
-            <a:ext cx="1691640" cy="457200"/>
+            <a:off x="685800" y="3410712"/>
+            <a:ext cx="1920240" cy="502920"/>
           </a:xfrm>
           <a:prstGeom prst="rect">
             <a:avLst/>
@@ -10164,7 +10184,7 @@
               </a:spcAft>
             </a:pPr>
             <a:r>
-              <a:rPr sz="1400" b="1" i="0">
+              <a:rPr sz="1600" b="1" i="0">
                 <a:solidFill>
                   <a:srgbClr val="0F8F85"/>
                 </a:solidFill>
@@ -10191,8 +10211,8 @@
         </p:blipFill>
         <p:spPr>
           <a:xfrm>
-            <a:off x="2468880" y="3218688"/>
-            <a:ext cx="2856613" cy="457200"/>
+            <a:off x="2651760" y="3374136"/>
+            <a:ext cx="3313672" cy="530352"/>
           </a:xfrm>
           <a:prstGeom prst="rect">
             <a:avLst/>
@@ -10207,8 +10227,8 @@
         </p:nvSpPr>
         <p:spPr>
           <a:xfrm>
-            <a:off x="685800" y="3968496"/>
-            <a:ext cx="1691640" cy="457200"/>
+            <a:off x="685800" y="4151376"/>
+            <a:ext cx="1920240" cy="502920"/>
           </a:xfrm>
           <a:prstGeom prst="rect">
             <a:avLst/>
@@ -10230,7 +10250,7 @@
               </a:spcAft>
             </a:pPr>
             <a:r>
-              <a:rPr sz="1400" b="1" i="0">
+              <a:rPr sz="1600" b="1" i="0">
                 <a:solidFill>
                   <a:srgbClr val="0F8F85"/>
                 </a:solidFill>
@@ -10257,8 +10277,8 @@
         </p:blipFill>
         <p:spPr>
           <a:xfrm>
-            <a:off x="2468880" y="3950207"/>
-            <a:ext cx="3737113" cy="457200"/>
+            <a:off x="2651760" y="4114800"/>
+            <a:ext cx="4206240" cy="514593"/>
           </a:xfrm>
           <a:prstGeom prst="rect">
             <a:avLst/>
@@ -10273,8 +10293,8 @@
         </p:nvSpPr>
         <p:spPr>
           <a:xfrm>
-            <a:off x="685800" y="4700016"/>
-            <a:ext cx="1691640" cy="457200"/>
+            <a:off x="685800" y="4892040"/>
+            <a:ext cx="1920240" cy="502920"/>
           </a:xfrm>
           <a:prstGeom prst="rect">
             <a:avLst/>
@@ -10296,7 +10316,7 @@
               </a:spcAft>
             </a:pPr>
             <a:r>
-              <a:rPr sz="1400" b="1" i="0">
+              <a:rPr sz="1600" b="1" i="0">
                 <a:solidFill>
                   <a:srgbClr val="0F8F85"/>
                 </a:solidFill>
@@ -10323,8 +10343,8 @@
         </p:blipFill>
         <p:spPr>
           <a:xfrm>
-            <a:off x="2468880" y="4681727"/>
-            <a:ext cx="2658139" cy="457199"/>
+            <a:off x="2651760" y="4855464"/>
+            <a:ext cx="3296093" cy="566928"/>
           </a:xfrm>
           <a:prstGeom prst="rect">
             <a:avLst/>
@@ -10339,8 +10359,8 @@
         </p:nvSpPr>
         <p:spPr>
           <a:xfrm>
-            <a:off x="685800" y="5431536"/>
-            <a:ext cx="1691640" cy="457200"/>
+            <a:off x="685800" y="5632704"/>
+            <a:ext cx="1920240" cy="502920"/>
           </a:xfrm>
           <a:prstGeom prst="rect">
             <a:avLst/>
@@ -10362,7 +10382,7 @@
               </a:spcAft>
             </a:pPr>
             <a:r>
-              <a:rPr sz="1400" b="1" i="0">
+              <a:rPr sz="1600" b="1" i="0">
                 <a:solidFill>
                   <a:srgbClr val="0F8F85"/>
                 </a:solidFill>
@@ -10389,8 +10409,8 @@
         </p:blipFill>
         <p:spPr>
           <a:xfrm>
-            <a:off x="2468880" y="5413247"/>
-            <a:ext cx="2122714" cy="457200"/>
+            <a:off x="2651760" y="5596128"/>
+            <a:ext cx="2632165" cy="566928"/>
           </a:xfrm>
           <a:prstGeom prst="rect">
             <a:avLst/>
@@ -10413,8 +10433,8 @@
         </p:blipFill>
         <p:spPr>
           <a:xfrm>
-            <a:off x="6583680" y="1645920"/>
-            <a:ext cx="5120640" cy="875898"/>
+            <a:off x="7223760" y="1783080"/>
+            <a:ext cx="4480560" cy="766411"/>
           </a:xfrm>
           <a:prstGeom prst="rect">
             <a:avLst/>
@@ -10434,8 +10454,8 @@
         </p:nvSpPr>
         <p:spPr>
           <a:xfrm>
-            <a:off x="6583680" y="2549250"/>
-            <a:ext cx="5120640" cy="320040"/>
+            <a:off x="7223760" y="2567779"/>
+            <a:ext cx="4480560" cy="274320"/>
           </a:xfrm>
           <a:prstGeom prst="rect">
             <a:avLst/>
@@ -10457,13 +10477,13 @@
               </a:spcAft>
             </a:pPr>
             <a:r>
-              <a:rPr sz="1100" b="0" i="1">
+              <a:rPr sz="1200" b="0" i="1">
                 <a:solidFill>
                   <a:srgbClr val="64748B"/>
                 </a:solidFill>
                 <a:latin typeface="Calibri"/>
               </a:rPr>
-              <a:t>Lambert · Phong · Blinn–Phong · Oren–Nayar · Cook–Torrance · Subsurface</a:t>
+              <a:t>Six models, one sphere each</a:t>
             </a:r>
           </a:p>
         </p:txBody>
@@ -10476,8 +10496,8 @@
         </p:nvSpPr>
         <p:spPr>
           <a:xfrm>
-            <a:off x="6583680" y="2933298"/>
-            <a:ext cx="5120640" cy="3421781"/>
+            <a:off x="7223760" y="2915251"/>
+            <a:ext cx="4480560" cy="3439828"/>
           </a:xfrm>
           <a:prstGeom prst="roundRect">
             <a:avLst>
@@ -10524,8 +10544,8 @@
         </p:nvSpPr>
         <p:spPr>
           <a:xfrm>
-            <a:off x="6720840" y="2969874"/>
-            <a:ext cx="4846320" cy="320040"/>
+            <a:off x="7360920" y="2951827"/>
+            <a:ext cx="4206240" cy="365760"/>
           </a:xfrm>
           <a:prstGeom prst="rect">
             <a:avLst/>
@@ -10547,7 +10567,7 @@
               </a:spcAft>
             </a:pPr>
             <a:r>
-              <a:rPr sz="1400" b="1" i="0">
+              <a:rPr sz="1700" b="1" i="0">
                 <a:solidFill>
                   <a:srgbClr val="0F8F85"/>
                 </a:solidFill>
@@ -10566,8 +10586,8 @@
         </p:nvSpPr>
         <p:spPr>
           <a:xfrm>
-            <a:off x="6720840" y="3317346"/>
-            <a:ext cx="4846320" cy="1417320"/>
+            <a:off x="7360920" y="3372451"/>
+            <a:ext cx="4206240" cy="1554480"/>
           </a:xfrm>
           <a:prstGeom prst="rect">
             <a:avLst/>
@@ -10585,7 +10605,7 @@
                 <a:spcPct val="100000"/>
               </a:lnSpc>
               <a:spcAft>
-                <a:spcPts val="200"/>
+                <a:spcPts val="300"/>
               </a:spcAft>
               <a:buClr>
                 <a:srgbClr val="007A3D"/>
@@ -10593,13 +10613,13 @@
               <a:buChar char="•"/>
             </a:pPr>
             <a:r>
-              <a:rPr sz="1400" b="0" i="0">
+              <a:rPr sz="1600" b="0" i="0">
                 <a:solidFill>
                   <a:srgbClr val="1E293B"/>
                 </a:solidFill>
                 <a:latin typeface="Calibri"/>
               </a:rPr>
-              <a:t>Directional: sun, moon (no falloff)</a:t>
+              <a:t>Directional: sun, moon</a:t>
             </a:r>
           </a:p>
           <a:p>
@@ -10608,7 +10628,7 @@
                 <a:spcPct val="100000"/>
               </a:lnSpc>
               <a:spcAft>
-                <a:spcPts val="200"/>
+                <a:spcPts val="300"/>
               </a:spcAft>
               <a:buClr>
                 <a:srgbClr val="007A3D"/>
@@ -10616,7 +10636,7 @@
               <a:buChar char="•"/>
             </a:pPr>
             <a:r>
-              <a:rPr sz="1400" b="0" i="0">
+              <a:rPr sz="1600" b="0" i="0">
                 <a:solidFill>
                   <a:srgbClr val="1E293B"/>
                 </a:solidFill>
@@ -10631,7 +10651,7 @@
                 <a:spcPct val="100000"/>
               </a:lnSpc>
               <a:spcAft>
-                <a:spcPts val="200"/>
+                <a:spcPts val="300"/>
               </a:spcAft>
               <a:buClr>
                 <a:srgbClr val="007A3D"/>
@@ -10639,13 +10659,13 @@
               <a:buChar char="•"/>
             </a:pPr>
             <a:r>
-              <a:rPr sz="1400" b="0" i="0">
+              <a:rPr sz="1600" b="0" i="0">
                 <a:solidFill>
                   <a:srgbClr val="1E293B"/>
                 </a:solidFill>
                 <a:latin typeface="Calibri"/>
               </a:rPr>
-              <a:t>Spot: floodlights; cone factor</a:t>
+              <a:t>Spot: floodlights (cone)</a:t>
             </a:r>
           </a:p>
           <a:p>
@@ -10654,7 +10674,7 @@
                 <a:spcPct val="100000"/>
               </a:lnSpc>
               <a:spcAft>
-                <a:spcPts val="200"/>
+                <a:spcPts val="300"/>
               </a:spcAft>
               <a:buClr>
                 <a:srgbClr val="007A3D"/>
@@ -10662,7 +10682,7 @@
               <a:buChar char="•"/>
             </a:pPr>
             <a:r>
-              <a:rPr sz="1400" b="0" i="0">
+              <a:rPr sz="1600" b="0" i="0">
                 <a:solidFill>
                   <a:srgbClr val="1E293B"/>
                 </a:solidFill>
@@ -10689,32 +10709,8 @@
         </p:blipFill>
         <p:spPr>
           <a:xfrm>
-            <a:off x="6766560" y="5394960"/>
-            <a:ext cx="2743200" cy="545077"/>
-          </a:xfrm>
-          <a:prstGeom prst="rect">
-            <a:avLst/>
-          </a:prstGeom>
-        </p:spPr>
-      </p:pic>
-      <p:pic>
-        <p:nvPicPr>
-          <p:cNvPr id="29" name="Picture 28" descr="spot.png"/>
-          <p:cNvPicPr>
-            <a:picLocks noChangeAspect="1"/>
-          </p:cNvPicPr>
-          <p:nvPr/>
-        </p:nvPicPr>
-        <p:blipFill>
-          <a:blip r:embed="rId13"/>
-          <a:stretch>
-            <a:fillRect/>
-          </a:stretch>
-        </p:blipFill>
-        <p:spPr>
-          <a:xfrm>
-            <a:off x="9601200" y="5440680"/>
-            <a:ext cx="2011680" cy="364784"/>
+            <a:off x="7360920" y="5257800"/>
+            <a:ext cx="3108960" cy="617754"/>
           </a:xfrm>
           <a:prstGeom prst="rect">
             <a:avLst/>
@@ -12027,7 +12023,7 @@
         <p:spPr>
           <a:xfrm>
             <a:off x="685800" y="2971800"/>
-            <a:ext cx="5943600" cy="320040"/>
+            <a:ext cx="5943600" cy="365760"/>
           </a:xfrm>
           <a:prstGeom prst="rect">
             <a:avLst/>
@@ -12049,7 +12045,7 @@
               </a:spcAft>
             </a:pPr>
             <a:r>
-              <a:rPr sz="1400" b="1" i="0">
+              <a:rPr sz="1600" b="1" i="0">
                 <a:solidFill>
                   <a:srgbClr val="0F8F85"/>
                 </a:solidFill>
@@ -12092,7 +12088,7 @@
         </p:nvSpPr>
         <p:spPr>
           <a:xfrm>
-            <a:off x="685800" y="4114800"/>
+            <a:off x="685800" y="4160520"/>
             <a:ext cx="5943600" cy="640080"/>
           </a:xfrm>
           <a:prstGeom prst="rect">
@@ -12115,7 +12111,7 @@
               </a:spcAft>
             </a:pPr>
             <a:r>
-              <a:rPr sz="1400" b="0" i="0">
+              <a:rPr sz="1500" b="0" i="0">
                 <a:solidFill>
                   <a:srgbClr val="1E293B"/>
                 </a:solidFill>
@@ -12134,8 +12130,8 @@
         </p:nvSpPr>
         <p:spPr>
           <a:xfrm>
-            <a:off x="685800" y="4663440"/>
-            <a:ext cx="5943600" cy="320040"/>
+            <a:off x="685800" y="4709160"/>
+            <a:ext cx="5943600" cy="365760"/>
           </a:xfrm>
           <a:prstGeom prst="rect">
             <a:avLst/>
@@ -12157,7 +12153,7 @@
               </a:spcAft>
             </a:pPr>
             <a:r>
-              <a:rPr sz="1400" b="1" i="0">
+              <a:rPr sz="1600" b="1" i="0">
                 <a:solidFill>
                   <a:srgbClr val="0F8F85"/>
                 </a:solidFill>
@@ -12224,8 +12220,8 @@
         </p:nvSpPr>
         <p:spPr>
           <a:xfrm>
-            <a:off x="685800" y="5806440"/>
-            <a:ext cx="6035040" cy="502920"/>
+            <a:off x="685800" y="5760720"/>
+            <a:ext cx="6035040" cy="548640"/>
           </a:xfrm>
           <a:prstGeom prst="rect">
             <a:avLst/>
@@ -12247,7 +12243,7 @@
               </a:spcAft>
             </a:pPr>
             <a:r>
-              <a:rPr sz="1300" b="0" i="0">
+              <a:rPr sz="1500" b="0" i="0">
                 <a:solidFill>
                   <a:srgbClr val="64748B"/>
                 </a:solidFill>
@@ -12360,7 +12356,7 @@
               </a:spcAft>
             </a:pPr>
             <a:r>
-              <a:rPr sz="1500" b="0" i="0">
+              <a:rPr sz="1600" b="0" i="0">
                 <a:solidFill>
                   <a:srgbClr val="1E293B"/>
                 </a:solidFill>

</xml_diff>

<commit_message>
Equations: summation limits above and below, piecewise cases, aligned definitions in slides and report; larger Phong equations
</commit_message>
<xml_diff>
--- a/Docs/Deliverables/Slides/Sentinel_Presentation.pptx
+++ b/Docs/Deliverables/Slides/Sentinel_Presentation.pptx
@@ -7833,8 +7833,8 @@
         </p:blipFill>
         <p:spPr>
           <a:xfrm>
-            <a:off x="1737360" y="1051560"/>
-            <a:ext cx="8686800" cy="1705384"/>
+            <a:off x="548640" y="1051560"/>
+            <a:ext cx="5486400" cy="1077084"/>
           </a:xfrm>
           <a:prstGeom prst="rect">
             <a:avLst/>
@@ -7856,8 +7856,8 @@
         </p:nvSpPr>
         <p:spPr>
           <a:xfrm>
-            <a:off x="1737360" y="2793520"/>
-            <a:ext cx="8686800" cy="274320"/>
+            <a:off x="548640" y="2156076"/>
+            <a:ext cx="5486400" cy="274320"/>
           </a:xfrm>
           <a:prstGeom prst="rect">
             <a:avLst/>
@@ -7898,8 +7898,8 @@
         </p:nvSpPr>
         <p:spPr>
           <a:xfrm>
-            <a:off x="548640" y="3214144"/>
-            <a:ext cx="5486400" cy="1874519"/>
+            <a:off x="548640" y="2540124"/>
+            <a:ext cx="5486400" cy="2331720"/>
           </a:xfrm>
           <a:prstGeom prst="roundRect">
             <a:avLst>
@@ -7952,8 +7952,8 @@
         </p:nvSpPr>
         <p:spPr>
           <a:xfrm>
-            <a:off x="548640" y="3323872"/>
-            <a:ext cx="64008" cy="1655063"/>
+            <a:off x="548640" y="2649852"/>
+            <a:ext cx="64008" cy="2112263"/>
           </a:xfrm>
           <a:prstGeom prst="rect">
             <a:avLst/>
@@ -7996,7 +7996,7 @@
         </p:nvSpPr>
         <p:spPr>
           <a:xfrm>
-            <a:off x="777240" y="3305584"/>
+            <a:off x="777240" y="2631564"/>
             <a:ext cx="5120640" cy="347472"/>
           </a:xfrm>
           <a:prstGeom prst="rect">
@@ -8046,8 +8046,8 @@
         </p:blipFill>
         <p:spPr>
           <a:xfrm>
-            <a:off x="1779308" y="3890800"/>
-            <a:ext cx="3025063" cy="868680"/>
+            <a:off x="2066323" y="2997324"/>
+            <a:ext cx="2451032" cy="1764792"/>
           </a:xfrm>
           <a:prstGeom prst="rect">
             <a:avLst/>
@@ -8062,8 +8062,8 @@
         </p:nvSpPr>
         <p:spPr>
           <a:xfrm>
-            <a:off x="548640" y="5225824"/>
-            <a:ext cx="5486400" cy="1129255"/>
+            <a:off x="548640" y="5009004"/>
+            <a:ext cx="5486400" cy="1346075"/>
           </a:xfrm>
           <a:prstGeom prst="roundRect">
             <a:avLst>
@@ -8116,8 +8116,8 @@
         </p:nvSpPr>
         <p:spPr>
           <a:xfrm>
-            <a:off x="548640" y="5335552"/>
-            <a:ext cx="64008" cy="909799"/>
+            <a:off x="548640" y="5118732"/>
+            <a:ext cx="64008" cy="1126619"/>
           </a:xfrm>
           <a:prstGeom prst="rect">
             <a:avLst/>
@@ -8160,7 +8160,7 @@
         </p:nvSpPr>
         <p:spPr>
           <a:xfrm>
-            <a:off x="777240" y="5317264"/>
+            <a:off x="777240" y="5100444"/>
             <a:ext cx="5120640" cy="347472"/>
           </a:xfrm>
           <a:prstGeom prst="rect">
@@ -8210,8 +8210,8 @@
         </p:blipFill>
         <p:spPr>
           <a:xfrm>
-            <a:off x="891539" y="5792738"/>
-            <a:ext cx="4800600" cy="342900"/>
+            <a:off x="868680" y="5729277"/>
+            <a:ext cx="4846320" cy="253001"/>
           </a:xfrm>
           <a:prstGeom prst="rect">
             <a:avLst/>
@@ -8226,8 +8226,8 @@
         </p:nvSpPr>
         <p:spPr>
           <a:xfrm>
-            <a:off x="6355080" y="3305584"/>
-            <a:ext cx="5394960" cy="3383280"/>
+            <a:off x="6355080" y="1097280"/>
+            <a:ext cx="5349240" cy="3017520"/>
           </a:xfrm>
           <a:prstGeom prst="rect">
             <a:avLst/>
@@ -8245,7 +8245,7 @@
                 <a:spcPct val="100000"/>
               </a:lnSpc>
               <a:spcAft>
-                <a:spcPts val="1100"/>
+                <a:spcPts val="900"/>
               </a:spcAft>
               <a:buClr>
                 <a:srgbClr val="0F8F85"/>
@@ -8253,7 +8253,7 @@
               <a:buChar char="▪"/>
             </a:pPr>
             <a:r>
-              <a:rPr sz="2000" b="0" i="0">
+              <a:rPr sz="1900" b="0" i="0">
                 <a:solidFill>
                   <a:srgbClr val="1E293B"/>
                 </a:solidFill>
@@ -8268,7 +8268,7 @@
                 <a:spcPct val="100000"/>
               </a:lnSpc>
               <a:spcAft>
-                <a:spcPts val="1100"/>
+                <a:spcPts val="900"/>
               </a:spcAft>
               <a:buClr>
                 <a:srgbClr val="0F8F85"/>
@@ -8276,7 +8276,7 @@
               <a:buChar char="▪"/>
             </a:pPr>
             <a:r>
-              <a:rPr sz="2000" b="0" i="0">
+              <a:rPr sz="1900" b="0" i="0">
                 <a:solidFill>
                   <a:srgbClr val="1E293B"/>
                 </a:solidFill>
@@ -8291,7 +8291,7 @@
                 <a:spcPct val="100000"/>
               </a:lnSpc>
               <a:spcAft>
-                <a:spcPts val="1100"/>
+                <a:spcPts val="900"/>
               </a:spcAft>
               <a:buClr>
                 <a:srgbClr val="0F8F85"/>
@@ -8299,7 +8299,7 @@
               <a:buChar char="▪"/>
             </a:pPr>
             <a:r>
-              <a:rPr sz="2000" b="0" i="0">
+              <a:rPr sz="1900" b="0" i="0">
                 <a:solidFill>
                   <a:srgbClr val="1E293B"/>
                 </a:solidFill>
@@ -8314,7 +8314,7 @@
                 <a:spcPct val="100000"/>
               </a:lnSpc>
               <a:spcAft>
-                <a:spcPts val="1100"/>
+                <a:spcPts val="900"/>
               </a:spcAft>
               <a:buClr>
                 <a:srgbClr val="0F8F85"/>
@@ -8322,13 +8322,91 @@
               <a:buChar char="▪"/>
             </a:pPr>
             <a:r>
-              <a:rPr sz="2000" b="0" i="0">
+              <a:rPr sz="1900" b="0" i="0">
                 <a:solidFill>
                   <a:srgbClr val="1E293B"/>
                 </a:solidFill>
                 <a:latin typeface="Calibri"/>
               </a:rPr>
               <a:t>Soldiers: skeletons with two-bone IK legs</a:t>
+            </a:r>
+          </a:p>
+        </p:txBody>
+      </p:sp>
+      <p:pic>
+        <p:nvPicPr>
+          <p:cNvPr id="20" name="Picture 19" descr="showroom.jpg"/>
+          <p:cNvPicPr>
+            <a:picLocks noChangeAspect="1"/>
+          </p:cNvPicPr>
+          <p:nvPr/>
+        </p:nvPicPr>
+        <p:blipFill>
+          <a:blip r:embed="rId7"/>
+          <a:stretch>
+            <a:fillRect/>
+          </a:stretch>
+        </p:blipFill>
+        <p:spPr>
+          <a:xfrm>
+            <a:off x="6766560" y="3931920"/>
+            <a:ext cx="4206240" cy="2366010"/>
+          </a:xfrm>
+          <a:prstGeom prst="rect">
+            <a:avLst/>
+          </a:prstGeom>
+          <a:ln w="28575">
+            <a:solidFill>
+              <a:srgbClr val="FFFFFF"/>
+            </a:solidFill>
+          </a:ln>
+          <a:effectLst>
+            <a:outerShdw blurRad="127000" dist="38100" dir="5400000" algn="t" rotWithShape="0">
+              <a:srgbClr val="0B1220">
+                <a:alpha val="24000"/>
+              </a:srgbClr>
+            </a:outerShdw>
+          </a:effectLst>
+        </p:spPr>
+      </p:pic>
+      <p:sp>
+        <p:nvSpPr>
+          <p:cNvPr id="21" name="TextBox 20"/>
+          <p:cNvSpPr txBox="1"/>
+          <p:nvPr/>
+        </p:nvSpPr>
+        <p:spPr>
+          <a:xfrm>
+            <a:off x="6766560" y="6334505"/>
+            <a:ext cx="4206240" cy="274320"/>
+          </a:xfrm>
+          <a:prstGeom prst="rect">
+            <a:avLst/>
+          </a:prstGeom>
+          <a:noFill/>
+        </p:spPr>
+        <p:txBody>
+          <a:bodyPr wrap="square" lIns="36576" rIns="36576" tIns="18288" bIns="18288" anchor="t">
+            <a:spAutoFit/>
+          </a:bodyPr>
+          <a:lstStyle/>
+          <a:p>
+            <a:pPr algn="ctr">
+              <a:lnSpc>
+                <a:spcPct val="100000"/>
+              </a:lnSpc>
+              <a:spcAft>
+                <a:spcPts val="400"/>
+              </a:spcAft>
+            </a:pPr>
+            <a:r>
+              <a:rPr sz="1200" b="0" i="1">
+                <a:solidFill>
+                  <a:srgbClr val="64748B"/>
+                </a:solidFill>
+                <a:latin typeface="Calibri"/>
+              </a:rPr>
+              <a:t>The material showroom: one sphere per recipe</a:t>
             </a:r>
           </a:p>
         </p:txBody>
@@ -9684,8 +9762,8 @@
         </p:blipFill>
         <p:spPr>
           <a:xfrm>
-            <a:off x="2358351" y="4867236"/>
-            <a:ext cx="2049856" cy="781126"/>
+            <a:off x="868680" y="4933558"/>
+            <a:ext cx="5029200" cy="648482"/>
           </a:xfrm>
           <a:prstGeom prst="rect">
             <a:avLst/>
@@ -10054,8 +10132,8 @@
         </p:blipFill>
         <p:spPr>
           <a:xfrm>
-            <a:off x="6766560" y="4538260"/>
-            <a:ext cx="4617720" cy="323510"/>
+            <a:off x="6766560" y="4541450"/>
+            <a:ext cx="4617720" cy="317130"/>
           </a:xfrm>
           <a:prstGeom prst="rect">
             <a:avLst/>
@@ -10515,7 +10593,7 @@
         <p:spPr>
           <a:xfrm>
             <a:off x="548640" y="1005840"/>
-            <a:ext cx="8046720" cy="1188720"/>
+            <a:ext cx="11155680" cy="1188720"/>
           </a:xfrm>
           <a:prstGeom prst="roundRect">
             <a:avLst>
@@ -10613,7 +10691,7 @@
         <p:spPr>
           <a:xfrm>
             <a:off x="777240" y="1097280"/>
-            <a:ext cx="7680960" cy="347472"/>
+            <a:ext cx="10789919" cy="347472"/>
           </a:xfrm>
           <a:prstGeom prst="rect">
             <a:avLst/>
@@ -10641,7 +10719,7 @@
                 </a:solidFill>
                 <a:latin typeface="Calibri"/>
               </a:rPr>
-              <a:t>DIRECT LIGHT + AMBIENT + EMISSION</a:t>
+              <a:t>DIRECT LIGHT + AMBIENT + EMISSION     (F: ILLUMINATION MODEL · ATT: FALLOFF · SH: SHADOW · N_L: NUMBER OF LIGHTS)</a:t>
             </a:r>
           </a:p>
         </p:txBody>
@@ -10662,8 +10740,8 @@
         </p:blipFill>
         <p:spPr>
           <a:xfrm>
-            <a:off x="1368057" y="1463040"/>
-            <a:ext cx="6407885" cy="621792"/>
+            <a:off x="3552097" y="1463040"/>
+            <a:ext cx="5148764" cy="621792"/>
           </a:xfrm>
           <a:prstGeom prst="rect">
             <a:avLst/>
@@ -10672,68 +10750,7 @@
       </p:pic>
       <p:sp>
         <p:nvSpPr>
-          <p:cNvPr id="13" name="TextBox 12"/>
-          <p:cNvSpPr txBox="1"/>
-          <p:nvPr/>
-        </p:nvSpPr>
-        <p:spPr>
-          <a:xfrm>
-            <a:off x="8778240" y="1234440"/>
-            <a:ext cx="3017520" cy="822960"/>
-          </a:xfrm>
-          <a:prstGeom prst="rect">
-            <a:avLst/>
-          </a:prstGeom>
-          <a:noFill/>
-        </p:spPr>
-        <p:txBody>
-          <a:bodyPr wrap="square" lIns="36576" rIns="36576" tIns="18288" bIns="18288" anchor="t">
-            <a:spAutoFit/>
-          </a:bodyPr>
-          <a:lstStyle/>
-          <a:p>
-            <a:pPr algn="l">
-              <a:lnSpc>
-                <a:spcPct val="100000"/>
-              </a:lnSpc>
-              <a:spcAft>
-                <a:spcPts val="0"/>
-              </a:spcAft>
-            </a:pPr>
-            <a:r>
-              <a:rPr sz="1300" b="0" i="1">
-                <a:solidFill>
-                  <a:srgbClr val="64748B"/>
-                </a:solidFill>
-                <a:latin typeface="Calibri"/>
-              </a:rPr>
-              <a:t>f = illumination model</a:t>
-            </a:r>
-          </a:p>
-          <a:p>
-            <a:pPr algn="l">
-              <a:lnSpc>
-                <a:spcPct val="100000"/>
-              </a:lnSpc>
-              <a:spcAft>
-                <a:spcPts val="0"/>
-              </a:spcAft>
-            </a:pPr>
-            <a:r>
-              <a:rPr sz="1300" b="0" i="1">
-                <a:solidFill>
-                  <a:srgbClr val="64748B"/>
-                </a:solidFill>
-                <a:latin typeface="Calibri"/>
-              </a:rPr>
-              <a:t>att = falloff   sh = shadow</a:t>
-            </a:r>
-          </a:p>
-        </p:txBody>
-      </p:sp>
-      <p:sp>
-        <p:nvSpPr>
-          <p:cNvPr id="14" name="Rounded Rectangle 13"/>
+          <p:cNvPr id="13" name="Rounded Rectangle 12"/>
           <p:cNvSpPr/>
           <p:nvPr/>
         </p:nvSpPr>
@@ -10787,7 +10804,7 @@
       </p:sp>
       <p:sp>
         <p:nvSpPr>
-          <p:cNvPr id="15" name="Rectangle 14"/>
+          <p:cNvPr id="14" name="Rectangle 13"/>
           <p:cNvSpPr/>
           <p:nvPr/>
         </p:nvSpPr>
@@ -10831,14 +10848,14 @@
       </p:sp>
       <p:sp>
         <p:nvSpPr>
-          <p:cNvPr id="16" name="TextBox 15"/>
+          <p:cNvPr id="15" name="TextBox 14"/>
           <p:cNvSpPr txBox="1"/>
           <p:nvPr/>
         </p:nvSpPr>
         <p:spPr>
           <a:xfrm>
             <a:off x="777240" y="2450592"/>
-            <a:ext cx="1920240" cy="502920"/>
+            <a:ext cx="1828800" cy="502920"/>
           </a:xfrm>
           <a:prstGeom prst="rect">
             <a:avLst/>
@@ -10873,7 +10890,7 @@
       </p:sp>
       <p:pic>
         <p:nvPicPr>
-          <p:cNvPr id="17" name="Picture 16" descr="lambert.png"/>
+          <p:cNvPr id="16" name="Picture 15" descr="lambert.png"/>
           <p:cNvPicPr>
             <a:picLocks noChangeAspect="1"/>
           </p:cNvPicPr>
@@ -10887,7 +10904,7 @@
         </p:blipFill>
         <p:spPr>
           <a:xfrm>
-            <a:off x="2743200" y="2441448"/>
+            <a:off x="2606040" y="2441448"/>
             <a:ext cx="725484" cy="481523"/>
           </a:xfrm>
           <a:prstGeom prst="rect">
@@ -10897,7 +10914,7 @@
       </p:pic>
       <p:sp>
         <p:nvSpPr>
-          <p:cNvPr id="18" name="Rectangle 17"/>
+          <p:cNvPr id="17" name="Rectangle 16"/>
           <p:cNvSpPr/>
           <p:nvPr/>
         </p:nvSpPr>
@@ -10941,14 +10958,14 @@
       </p:sp>
       <p:sp>
         <p:nvSpPr>
-          <p:cNvPr id="19" name="TextBox 18"/>
+          <p:cNvPr id="18" name="TextBox 17"/>
           <p:cNvSpPr txBox="1"/>
           <p:nvPr/>
         </p:nvSpPr>
         <p:spPr>
           <a:xfrm>
             <a:off x="777240" y="3099816"/>
-            <a:ext cx="1920240" cy="502920"/>
+            <a:ext cx="1828800" cy="502920"/>
           </a:xfrm>
           <a:prstGeom prst="rect">
             <a:avLst/>
@@ -10983,7 +11000,7 @@
       </p:sp>
       <p:pic>
         <p:nvPicPr>
-          <p:cNvPr id="20" name="Picture 19" descr="phong.png"/>
+          <p:cNvPr id="19" name="Picture 18" descr="phong.png"/>
           <p:cNvPicPr>
             <a:picLocks noChangeAspect="1"/>
           </p:cNvPicPr>
@@ -10997,8 +11014,8 @@
         </p:blipFill>
         <p:spPr>
           <a:xfrm>
-            <a:off x="2743200" y="3090672"/>
-            <a:ext cx="3345770" cy="530352"/>
+            <a:off x="2606040" y="3090672"/>
+            <a:ext cx="3630989" cy="548640"/>
           </a:xfrm>
           <a:prstGeom prst="rect">
             <a:avLst/>
@@ -11007,7 +11024,7 @@
       </p:pic>
       <p:sp>
         <p:nvSpPr>
-          <p:cNvPr id="21" name="Rectangle 20"/>
+          <p:cNvPr id="20" name="Rectangle 19"/>
           <p:cNvSpPr/>
           <p:nvPr/>
         </p:nvSpPr>
@@ -11051,14 +11068,14 @@
       </p:sp>
       <p:sp>
         <p:nvSpPr>
-          <p:cNvPr id="22" name="TextBox 21"/>
+          <p:cNvPr id="21" name="TextBox 20"/>
           <p:cNvSpPr txBox="1"/>
           <p:nvPr/>
         </p:nvSpPr>
         <p:spPr>
           <a:xfrm>
             <a:off x="777240" y="3749039"/>
-            <a:ext cx="1920240" cy="502920"/>
+            <a:ext cx="1828800" cy="502920"/>
           </a:xfrm>
           <a:prstGeom prst="rect">
             <a:avLst/>
@@ -11093,7 +11110,7 @@
       </p:sp>
       <p:pic>
         <p:nvPicPr>
-          <p:cNvPr id="23" name="Picture 22" descr="blinn.png"/>
+          <p:cNvPr id="22" name="Picture 21" descr="blinn.png"/>
           <p:cNvPicPr>
             <a:picLocks noChangeAspect="1"/>
           </p:cNvPicPr>
@@ -11107,8 +11124,8 @@
         </p:blipFill>
         <p:spPr>
           <a:xfrm>
-            <a:off x="2743200" y="3739896"/>
-            <a:ext cx="3392705" cy="530352"/>
+            <a:off x="2606040" y="3739896"/>
+            <a:ext cx="3676451" cy="548640"/>
           </a:xfrm>
           <a:prstGeom prst="rect">
             <a:avLst/>
@@ -11117,7 +11134,7 @@
       </p:pic>
       <p:sp>
         <p:nvSpPr>
-          <p:cNvPr id="24" name="Rectangle 23"/>
+          <p:cNvPr id="23" name="Rectangle 22"/>
           <p:cNvSpPr/>
           <p:nvPr/>
         </p:nvSpPr>
@@ -11161,14 +11178,14 @@
       </p:sp>
       <p:sp>
         <p:nvSpPr>
-          <p:cNvPr id="25" name="TextBox 24"/>
+          <p:cNvPr id="24" name="TextBox 23"/>
           <p:cNvSpPr txBox="1"/>
           <p:nvPr/>
         </p:nvSpPr>
         <p:spPr>
           <a:xfrm>
             <a:off x="777240" y="4398264"/>
-            <a:ext cx="1920240" cy="502920"/>
+            <a:ext cx="1828800" cy="502920"/>
           </a:xfrm>
           <a:prstGeom prst="rect">
             <a:avLst/>
@@ -11203,7 +11220,7 @@
       </p:sp>
       <p:pic>
         <p:nvPicPr>
-          <p:cNvPr id="26" name="Picture 25" descr="oren.png"/>
+          <p:cNvPr id="25" name="Picture 24" descr="oren.png"/>
           <p:cNvPicPr>
             <a:picLocks noChangeAspect="1"/>
           </p:cNvPicPr>
@@ -11217,8 +11234,8 @@
         </p:blipFill>
         <p:spPr>
           <a:xfrm>
-            <a:off x="2743200" y="4389120"/>
-            <a:ext cx="4023360" cy="461932"/>
+            <a:off x="2606040" y="4389120"/>
+            <a:ext cx="4206240" cy="463060"/>
           </a:xfrm>
           <a:prstGeom prst="rect">
             <a:avLst/>
@@ -11227,7 +11244,7 @@
       </p:pic>
       <p:sp>
         <p:nvSpPr>
-          <p:cNvPr id="27" name="Rectangle 26"/>
+          <p:cNvPr id="26" name="Rectangle 25"/>
           <p:cNvSpPr/>
           <p:nvPr/>
         </p:nvSpPr>
@@ -11271,14 +11288,14 @@
       </p:sp>
       <p:sp>
         <p:nvSpPr>
-          <p:cNvPr id="28" name="TextBox 27"/>
+          <p:cNvPr id="27" name="TextBox 26"/>
           <p:cNvSpPr txBox="1"/>
           <p:nvPr/>
         </p:nvSpPr>
         <p:spPr>
           <a:xfrm>
             <a:off x="777240" y="5047488"/>
-            <a:ext cx="1920240" cy="502920"/>
+            <a:ext cx="1828800" cy="502920"/>
           </a:xfrm>
           <a:prstGeom prst="rect">
             <a:avLst/>
@@ -11313,7 +11330,7 @@
       </p:sp>
       <p:pic>
         <p:nvPicPr>
-          <p:cNvPr id="29" name="Picture 28" descr="ct2.png"/>
+          <p:cNvPr id="28" name="Picture 27" descr="ct2.png"/>
           <p:cNvPicPr>
             <a:picLocks noChangeAspect="1"/>
           </p:cNvPicPr>
@@ -11327,8 +11344,8 @@
         </p:blipFill>
         <p:spPr>
           <a:xfrm>
-            <a:off x="2743200" y="5038344"/>
-            <a:ext cx="3146602" cy="530352"/>
+            <a:off x="2606040" y="5038344"/>
+            <a:ext cx="3255106" cy="548640"/>
           </a:xfrm>
           <a:prstGeom prst="rect">
             <a:avLst/>
@@ -11337,7 +11354,7 @@
       </p:pic>
       <p:sp>
         <p:nvSpPr>
-          <p:cNvPr id="30" name="Rectangle 29"/>
+          <p:cNvPr id="29" name="Rectangle 28"/>
           <p:cNvSpPr/>
           <p:nvPr/>
         </p:nvSpPr>
@@ -11381,14 +11398,14 @@
       </p:sp>
       <p:sp>
         <p:nvSpPr>
-          <p:cNvPr id="31" name="TextBox 30"/>
+          <p:cNvPr id="30" name="TextBox 29"/>
           <p:cNvSpPr txBox="1"/>
           <p:nvPr/>
         </p:nvSpPr>
         <p:spPr>
           <a:xfrm>
             <a:off x="777240" y="5696712"/>
-            <a:ext cx="1920240" cy="502920"/>
+            <a:ext cx="1828800" cy="502920"/>
           </a:xfrm>
           <a:prstGeom prst="rect">
             <a:avLst/>
@@ -11423,7 +11440,7 @@
       </p:sp>
       <p:pic>
         <p:nvPicPr>
-          <p:cNvPr id="32" name="Picture 31" descr="sss.png"/>
+          <p:cNvPr id="31" name="Picture 30" descr="sss.png"/>
           <p:cNvPicPr>
             <a:picLocks noChangeAspect="1"/>
           </p:cNvPicPr>
@@ -11437,102 +11454,24 @@
         </p:blipFill>
         <p:spPr>
           <a:xfrm>
-            <a:off x="2743200" y="5687568"/>
-            <a:ext cx="2981815" cy="530352"/>
+            <a:off x="2606040" y="5687568"/>
+            <a:ext cx="3843144" cy="548640"/>
           </a:xfrm>
           <a:prstGeom prst="rect">
             <a:avLst/>
           </a:prstGeom>
         </p:spPr>
       </p:pic>
-      <p:pic>
-        <p:nvPicPr>
-          <p:cNvPr id="33" name="Picture 32" descr="models.jpg"/>
-          <p:cNvPicPr>
-            <a:picLocks noChangeAspect="1"/>
-          </p:cNvPicPr>
-          <p:nvPr/>
-        </p:nvPicPr>
-        <p:blipFill>
-          <a:blip r:embed="rId11"/>
-          <a:stretch>
-            <a:fillRect/>
-          </a:stretch>
-        </p:blipFill>
+      <p:sp>
+        <p:nvSpPr>
+          <p:cNvPr id="32" name="Rounded Rectangle 31"/>
+          <p:cNvSpPr/>
+          <p:nvPr/>
+        </p:nvSpPr>
         <p:spPr>
           <a:xfrm>
             <a:off x="7223760" y="2331720"/>
-            <a:ext cx="4480560" cy="766411"/>
-          </a:xfrm>
-          <a:prstGeom prst="rect">
-            <a:avLst/>
-          </a:prstGeom>
-          <a:ln w="28575">
-            <a:solidFill>
-              <a:srgbClr val="FFFFFF"/>
-            </a:solidFill>
-          </a:ln>
-          <a:effectLst>
-            <a:outerShdw blurRad="127000" dist="38100" dir="5400000" algn="t" rotWithShape="0">
-              <a:srgbClr val="0B1220">
-                <a:alpha val="24000"/>
-              </a:srgbClr>
-            </a:outerShdw>
-          </a:effectLst>
-        </p:spPr>
-      </p:pic>
-      <p:sp>
-        <p:nvSpPr>
-          <p:cNvPr id="34" name="TextBox 33"/>
-          <p:cNvSpPr txBox="1"/>
-          <p:nvPr/>
-        </p:nvSpPr>
-        <p:spPr>
-          <a:xfrm>
-            <a:off x="7223760" y="3125563"/>
-            <a:ext cx="4480560" cy="274320"/>
-          </a:xfrm>
-          <a:prstGeom prst="rect">
-            <a:avLst/>
-          </a:prstGeom>
-          <a:noFill/>
-        </p:spPr>
-        <p:txBody>
-          <a:bodyPr wrap="square" lIns="36576" rIns="36576" tIns="18288" bIns="18288" anchor="t">
-            <a:spAutoFit/>
-          </a:bodyPr>
-          <a:lstStyle/>
-          <a:p>
-            <a:pPr algn="ctr">
-              <a:lnSpc>
-                <a:spcPct val="100000"/>
-              </a:lnSpc>
-              <a:spcAft>
-                <a:spcPts val="400"/>
-              </a:spcAft>
-            </a:pPr>
-            <a:r>
-              <a:rPr sz="1200" b="0" i="1">
-                <a:solidFill>
-                  <a:srgbClr val="64748B"/>
-                </a:solidFill>
-                <a:latin typeface="Calibri"/>
-              </a:rPr>
-              <a:t>Lambert · Phong · Blinn–Phong · Oren–Nayar · Cook–Torrance · Subsurface</a:t>
-            </a:r>
-          </a:p>
-        </p:txBody>
-      </p:sp>
-      <p:sp>
-        <p:nvSpPr>
-          <p:cNvPr id="35" name="Rounded Rectangle 34"/>
-          <p:cNvSpPr/>
-          <p:nvPr/>
-        </p:nvSpPr>
-        <p:spPr>
-          <a:xfrm>
-            <a:off x="7223760" y="3482179"/>
-            <a:ext cx="4480560" cy="2872900"/>
+            <a:ext cx="4480560" cy="1600200"/>
           </a:xfrm>
           <a:prstGeom prst="roundRect">
             <a:avLst>
@@ -11579,14 +11518,14 @@
       </p:sp>
       <p:sp>
         <p:nvSpPr>
-          <p:cNvPr id="36" name="Rectangle 35"/>
+          <p:cNvPr id="33" name="Rectangle 32"/>
           <p:cNvSpPr/>
           <p:nvPr/>
         </p:nvSpPr>
         <p:spPr>
           <a:xfrm>
-            <a:off x="7223760" y="3591907"/>
-            <a:ext cx="64008" cy="2653444"/>
+            <a:off x="7223760" y="2441448"/>
+            <a:ext cx="64008" cy="1380744"/>
           </a:xfrm>
           <a:prstGeom prst="rect">
             <a:avLst/>
@@ -11623,13 +11562,13 @@
       </p:sp>
       <p:sp>
         <p:nvSpPr>
-          <p:cNvPr id="37" name="TextBox 36"/>
+          <p:cNvPr id="34" name="TextBox 33"/>
           <p:cNvSpPr txBox="1"/>
           <p:nvPr/>
         </p:nvSpPr>
         <p:spPr>
           <a:xfrm>
-            <a:off x="7452360" y="3573619"/>
+            <a:off x="7452360" y="2423160"/>
             <a:ext cx="4114800" cy="347472"/>
           </a:xfrm>
           <a:prstGeom prst="rect">
@@ -11665,14 +11604,14 @@
       </p:sp>
       <p:sp>
         <p:nvSpPr>
-          <p:cNvPr id="38" name="TextBox 37"/>
+          <p:cNvPr id="35" name="TextBox 34"/>
           <p:cNvSpPr txBox="1"/>
           <p:nvPr/>
         </p:nvSpPr>
         <p:spPr>
           <a:xfrm>
-            <a:off x="7452360" y="3921091"/>
-            <a:ext cx="4114800" cy="1325880"/>
+            <a:off x="7452360" y="2697480"/>
+            <a:ext cx="4114800" cy="365760"/>
           </a:xfrm>
           <a:prstGeom prst="rect">
             <a:avLst/>
@@ -11685,102 +11624,193 @@
           </a:bodyPr>
           <a:lstStyle/>
           <a:p>
-            <a:pPr algn="l" marL="274320" indent="-274320">
-              <a:lnSpc>
-                <a:spcPct val="100000"/>
-              </a:lnSpc>
-              <a:spcAft>
-                <a:spcPts val="200"/>
-              </a:spcAft>
-              <a:buClr>
-                <a:srgbClr val="0F8F85"/>
-              </a:buClr>
-              <a:buChar char="▪"/>
-            </a:pPr>
-            <a:r>
-              <a:rPr sz="1500" b="0" i="0">
-                <a:solidFill>
-                  <a:srgbClr val="1E293B"/>
+            <a:pPr algn="l">
+              <a:lnSpc>
+                <a:spcPct val="100000"/>
+              </a:lnSpc>
+              <a:spcAft>
+                <a:spcPts val="400"/>
+              </a:spcAft>
+            </a:pPr>
+            <a:r>
+              <a:rPr sz="1300" b="0" i="0">
+                <a:solidFill>
+                  <a:srgbClr val="64748B"/>
                 </a:solidFill>
                 <a:latin typeface="Calibri"/>
               </a:rPr>
-              <a:t>Directional: sun, moon</a:t>
-            </a:r>
-          </a:p>
-          <a:p>
-            <a:pPr algn="l" marL="274320" indent="-274320">
-              <a:lnSpc>
-                <a:spcPct val="100000"/>
-              </a:lnSpc>
-              <a:spcAft>
-                <a:spcPts val="200"/>
-              </a:spcAft>
-              <a:buClr>
-                <a:srgbClr val="0F8F85"/>
-              </a:buClr>
-              <a:buChar char="▪"/>
-            </a:pPr>
-            <a:r>
-              <a:rPr sz="1500" b="0" i="0">
-                <a:solidFill>
-                  <a:srgbClr val="1E293B"/>
-                </a:solidFill>
-                <a:latin typeface="Calibri"/>
-              </a:rPr>
-              <a:t>Point: lamps, flashes</a:t>
-            </a:r>
-          </a:p>
-          <a:p>
-            <a:pPr algn="l" marL="274320" indent="-274320">
-              <a:lnSpc>
-                <a:spcPct val="100000"/>
-              </a:lnSpc>
-              <a:spcAft>
-                <a:spcPts val="200"/>
-              </a:spcAft>
-              <a:buClr>
-                <a:srgbClr val="0F8F85"/>
-              </a:buClr>
-              <a:buChar char="▪"/>
-            </a:pPr>
-            <a:r>
-              <a:rPr sz="1500" b="0" i="0">
-                <a:solidFill>
-                  <a:srgbClr val="1E293B"/>
-                </a:solidFill>
-                <a:latin typeface="Calibri"/>
-              </a:rPr>
-              <a:t>Spot: floodlights (cone)</a:t>
-            </a:r>
-          </a:p>
-          <a:p>
-            <a:pPr algn="l" marL="274320" indent="-274320">
-              <a:lnSpc>
-                <a:spcPct val="100000"/>
-              </a:lnSpc>
-              <a:spcAft>
-                <a:spcPts val="200"/>
-              </a:spcAft>
-              <a:buClr>
-                <a:srgbClr val="0F8F85"/>
-              </a:buClr>
-              <a:buChar char="▪"/>
-            </a:pPr>
-            <a:r>
-              <a:rPr sz="1500" b="0" i="0">
-                <a:solidFill>
-                  <a:srgbClr val="1E293B"/>
-                </a:solidFill>
-                <a:latin typeface="Calibri"/>
-              </a:rPr>
-              <a:t>Area: 4×4 point samples</a:t>
+              <a:t>Directional · Point · Spot · Area (4×4 samples)</a:t>
             </a:r>
           </a:p>
         </p:txBody>
       </p:sp>
       <p:pic>
         <p:nvPicPr>
-          <p:cNvPr id="39" name="Picture 38" descr="att.png"/>
+          <p:cNvPr id="36" name="Picture 35" descr="att.png"/>
+          <p:cNvPicPr>
+            <a:picLocks noChangeAspect="1"/>
+          </p:cNvPicPr>
+          <p:nvPr/>
+        </p:nvPicPr>
+        <p:blipFill>
+          <a:blip r:embed="rId11"/>
+          <a:stretch>
+            <a:fillRect/>
+          </a:stretch>
+        </p:blipFill>
+        <p:spPr>
+          <a:xfrm>
+            <a:off x="7976516" y="3017520"/>
+            <a:ext cx="2975046" cy="868680"/>
+          </a:xfrm>
+          <a:prstGeom prst="rect">
+            <a:avLst/>
+          </a:prstGeom>
+        </p:spPr>
+      </p:pic>
+      <p:sp>
+        <p:nvSpPr>
+          <p:cNvPr id="37" name="Rounded Rectangle 36"/>
+          <p:cNvSpPr/>
+          <p:nvPr/>
+        </p:nvSpPr>
+        <p:spPr>
+          <a:xfrm>
+            <a:off x="7223760" y="4069080"/>
+            <a:ext cx="4480560" cy="2286000"/>
+          </a:xfrm>
+          <a:prstGeom prst="roundRect">
+            <a:avLst>
+              <a:gd name="adj" fmla="val 4000"/>
+            </a:avLst>
+          </a:prstGeom>
+          <a:solidFill>
+            <a:srgbClr val="FFFFFF"/>
+          </a:solidFill>
+          <a:ln w="9525">
+            <a:solidFill>
+              <a:srgbClr val="DDE5EE"/>
+            </a:solidFill>
+          </a:ln>
+          <a:effectLst>
+            <a:outerShdw blurRad="114300" dist="25400" dir="5400000" algn="t" rotWithShape="0">
+              <a:srgbClr val="0B1220">
+                <a:alpha val="16000"/>
+              </a:srgbClr>
+            </a:outerShdw>
+          </a:effectLst>
+        </p:spPr>
+        <p:style>
+          <a:lnRef idx="1">
+            <a:schemeClr val="accent1"/>
+          </a:lnRef>
+          <a:fillRef idx="3">
+            <a:schemeClr val="accent1"/>
+          </a:fillRef>
+          <a:effectRef idx="2">
+            <a:schemeClr val="accent1"/>
+          </a:effectRef>
+          <a:fontRef idx="minor">
+            <a:schemeClr val="lt1"/>
+          </a:fontRef>
+        </p:style>
+        <p:txBody>
+          <a:bodyPr rtlCol="0" anchor="ctr"/>
+          <a:lstStyle/>
+          <a:p>
+            <a:pPr algn="ctr"/>
+          </a:p>
+        </p:txBody>
+      </p:sp>
+      <p:sp>
+        <p:nvSpPr>
+          <p:cNvPr id="38" name="Rectangle 37"/>
+          <p:cNvSpPr/>
+          <p:nvPr/>
+        </p:nvSpPr>
+        <p:spPr>
+          <a:xfrm>
+            <a:off x="7223760" y="4178808"/>
+            <a:ext cx="64008" cy="2066543"/>
+          </a:xfrm>
+          <a:prstGeom prst="rect">
+            <a:avLst/>
+          </a:prstGeom>
+          <a:solidFill>
+            <a:srgbClr val="0F8F85"/>
+          </a:solidFill>
+          <a:ln>
+            <a:noFill/>
+          </a:ln>
+          <a:effectLst/>
+        </p:spPr>
+        <p:style>
+          <a:lnRef idx="1">
+            <a:schemeClr val="accent1"/>
+          </a:lnRef>
+          <a:fillRef idx="3">
+            <a:schemeClr val="accent1"/>
+          </a:fillRef>
+          <a:effectRef idx="2">
+            <a:schemeClr val="accent1"/>
+          </a:effectRef>
+          <a:fontRef idx="minor">
+            <a:schemeClr val="lt1"/>
+          </a:fontRef>
+        </p:style>
+        <p:txBody>
+          <a:bodyPr rtlCol="0" anchor="ctr"/>
+          <a:lstStyle/>
+          <a:p>
+            <a:pPr algn="ctr"/>
+          </a:p>
+        </p:txBody>
+      </p:sp>
+      <p:sp>
+        <p:nvSpPr>
+          <p:cNvPr id="39" name="TextBox 38"/>
+          <p:cNvSpPr txBox="1"/>
+          <p:nvPr/>
+        </p:nvSpPr>
+        <p:spPr>
+          <a:xfrm>
+            <a:off x="7452360" y="4160520"/>
+            <a:ext cx="4114800" cy="347472"/>
+          </a:xfrm>
+          <a:prstGeom prst="rect">
+            <a:avLst/>
+          </a:prstGeom>
+          <a:noFill/>
+        </p:spPr>
+        <p:txBody>
+          <a:bodyPr wrap="square" lIns="36576" rIns="36576" tIns="18288" bIns="18288" anchor="t">
+            <a:spAutoFit/>
+          </a:bodyPr>
+          <a:lstStyle/>
+          <a:p>
+            <a:pPr algn="l">
+              <a:lnSpc>
+                <a:spcPct val="100000"/>
+              </a:lnSpc>
+              <a:spcAft>
+                <a:spcPts val="400"/>
+              </a:spcAft>
+            </a:pPr>
+            <a:r>
+              <a:rPr sz="1200" b="1" i="0">
+                <a:solidFill>
+                  <a:srgbClr val="0F8F85"/>
+                </a:solidFill>
+                <a:latin typeface="Calibri"/>
+              </a:rPr>
+              <a:t>DEFINITIONS USED ABOVE</a:t>
+            </a:r>
+          </a:p>
+        </p:txBody>
+      </p:sp>
+      <p:pic>
+        <p:nvPicPr>
+          <p:cNvPr id="40" name="Picture 39" descr="defs.png"/>
           <p:cNvPicPr>
             <a:picLocks noChangeAspect="1"/>
           </p:cNvPicPr>
@@ -11794,8 +11824,32 @@
         </p:blipFill>
         <p:spPr>
           <a:xfrm>
-            <a:off x="7779989" y="5577840"/>
-            <a:ext cx="3368100" cy="640080"/>
+            <a:off x="7543800" y="4740606"/>
+            <a:ext cx="3840480" cy="831154"/>
+          </a:xfrm>
+          <a:prstGeom prst="rect">
+            <a:avLst/>
+          </a:prstGeom>
+        </p:spPr>
+      </p:pic>
+      <p:pic>
+        <p:nvPicPr>
+          <p:cNvPr id="41" name="Picture 40" descr="ctdefs.png"/>
+          <p:cNvPicPr>
+            <a:picLocks noChangeAspect="1"/>
+          </p:cNvPicPr>
+          <p:nvPr/>
+        </p:nvPicPr>
+        <p:blipFill>
+          <a:blip r:embed="rId13"/>
+          <a:stretch>
+            <a:fillRect/>
+          </a:stretch>
+        </p:blipFill>
+        <p:spPr>
+          <a:xfrm>
+            <a:off x="7543800" y="5681488"/>
+            <a:ext cx="3840480" cy="349536"/>
           </a:xfrm>
           <a:prstGeom prst="rect">
             <a:avLst/>
@@ -13075,8 +13129,8 @@
         </p:blipFill>
         <p:spPr>
           <a:xfrm>
-            <a:off x="1313044" y="3337560"/>
-            <a:ext cx="4780551" cy="640079"/>
+            <a:off x="868680" y="3358920"/>
+            <a:ext cx="5669280" cy="597359"/>
           </a:xfrm>
           <a:prstGeom prst="rect">
             <a:avLst/>
@@ -13281,8 +13335,8 @@
         </p:blipFill>
         <p:spPr>
           <a:xfrm>
-            <a:off x="1744031" y="5212080"/>
-            <a:ext cx="3918577" cy="324076"/>
+            <a:off x="918171" y="5217858"/>
+            <a:ext cx="5570296" cy="384733"/>
           </a:xfrm>
           <a:prstGeom prst="rect">
             <a:avLst/>
@@ -13305,8 +13359,8 @@
         </p:blipFill>
         <p:spPr>
           <a:xfrm>
-            <a:off x="2113070" y="5613180"/>
-            <a:ext cx="3180498" cy="632171"/>
+            <a:off x="868680" y="5694032"/>
+            <a:ext cx="5669280" cy="545541"/>
           </a:xfrm>
           <a:prstGeom prst="rect">
             <a:avLst/>

</xml_diff>

<commit_message>
Final polish: margin fixes in the report, updated Equation Guide, slide layout and symbol legend
</commit_message>
<xml_diff>
--- a/Docs/Deliverables/Slides/Sentinel_Presentation.pptx
+++ b/Docs/Deliverables/Slides/Sentinel_Presentation.pptx
@@ -8046,8 +8046,8 @@
         </p:blipFill>
         <p:spPr>
           <a:xfrm>
-            <a:off x="2066323" y="2997324"/>
-            <a:ext cx="2451032" cy="1764792"/>
+            <a:off x="2034574" y="2951604"/>
+            <a:ext cx="2514530" cy="1810511"/>
           </a:xfrm>
           <a:prstGeom prst="rect">
             <a:avLst/>
@@ -8210,7 +8210,7 @@
         </p:blipFill>
         <p:spPr>
           <a:xfrm>
-            <a:off x="868680" y="5729277"/>
+            <a:off x="868680" y="5706417"/>
             <a:ext cx="4846320" cy="253001"/>
           </a:xfrm>
           <a:prstGeom prst="rect">
@@ -8349,8 +8349,8 @@
         </p:blipFill>
         <p:spPr>
           <a:xfrm>
-            <a:off x="6766560" y="3931920"/>
-            <a:ext cx="4206240" cy="2366010"/>
+            <a:off x="6492240" y="3429000"/>
+            <a:ext cx="5120640" cy="2880360"/>
           </a:xfrm>
           <a:prstGeom prst="rect">
             <a:avLst/>
@@ -8377,8 +8377,8 @@
         </p:nvSpPr>
         <p:spPr>
           <a:xfrm>
-            <a:off x="6766560" y="6334505"/>
-            <a:ext cx="4206240" cy="274320"/>
+            <a:off x="6492240" y="6364224"/>
+            <a:ext cx="5120640" cy="274320"/>
           </a:xfrm>
           <a:prstGeom prst="rect">
             <a:avLst/>
@@ -9537,7 +9537,7 @@
         </p:blipFill>
         <p:spPr>
           <a:xfrm>
-            <a:off x="1104938" y="2838411"/>
+            <a:off x="1104938" y="2824695"/>
             <a:ext cx="4556683" cy="358216"/>
           </a:xfrm>
           <a:prstGeom prst="rect">
@@ -9553,8 +9553,8 @@
         </p:nvSpPr>
         <p:spPr>
           <a:xfrm>
-            <a:off x="777240" y="3602735"/>
-            <a:ext cx="5303520" cy="566928"/>
+            <a:off x="777240" y="3694175"/>
+            <a:ext cx="5303520" cy="493776"/>
           </a:xfrm>
           <a:prstGeom prst="rect">
             <a:avLst/>
@@ -9562,7 +9562,7 @@
           <a:noFill/>
         </p:spPr>
         <p:txBody>
-          <a:bodyPr wrap="square" lIns="36576" rIns="36576" tIns="18288" bIns="18288" anchor="ctr">
+          <a:bodyPr wrap="square" lIns="36576" rIns="36576" tIns="18288" bIns="18288" anchor="b">
             <a:spAutoFit/>
           </a:bodyPr>
           <a:lstStyle/>
@@ -9572,11 +9572,11 @@
                 <a:spcPct val="100000"/>
               </a:lnSpc>
               <a:spcAft>
-                <a:spcPts val="100"/>
-              </a:spcAft>
-            </a:pPr>
-            <a:r>
-              <a:rPr sz="1300" b="0" i="0">
+                <a:spcPts val="0"/>
+              </a:spcAft>
+            </a:pPr>
+            <a:r>
+              <a:rPr sz="1200" b="0" i="0">
                 <a:solidFill>
                   <a:srgbClr val="64748B"/>
                 </a:solidFill>
@@ -9591,11 +9591,11 @@
                 <a:spcPct val="100000"/>
               </a:lnSpc>
               <a:spcAft>
-                <a:spcPts val="100"/>
-              </a:spcAft>
-            </a:pPr>
-            <a:r>
-              <a:rPr sz="1300" b="0" i="0">
+                <a:spcPts val="0"/>
+              </a:spcAft>
+            </a:pPr>
+            <a:r>
+              <a:rPr sz="1200" b="0" i="0">
                 <a:solidFill>
                   <a:srgbClr val="64748B"/>
                 </a:solidFill>
@@ -9762,7 +9762,7 @@
         </p:blipFill>
         <p:spPr>
           <a:xfrm>
-            <a:off x="868680" y="4933558"/>
+            <a:off x="868680" y="5011282"/>
             <a:ext cx="5029200" cy="648482"/>
           </a:xfrm>
           <a:prstGeom prst="rect">
@@ -9778,8 +9778,8 @@
         </p:nvSpPr>
         <p:spPr>
           <a:xfrm>
-            <a:off x="777240" y="5751576"/>
-            <a:ext cx="5303520" cy="566928"/>
+            <a:off x="777240" y="6044184"/>
+            <a:ext cx="5303520" cy="292608"/>
           </a:xfrm>
           <a:prstGeom prst="rect">
             <a:avLst/>
@@ -9787,7 +9787,7 @@
           <a:noFill/>
         </p:spPr>
         <p:txBody>
-          <a:bodyPr wrap="square" lIns="36576" rIns="36576" tIns="18288" bIns="18288" anchor="ctr">
+          <a:bodyPr wrap="square" lIns="36576" rIns="36576" tIns="18288" bIns="18288" anchor="b">
             <a:spAutoFit/>
           </a:bodyPr>
           <a:lstStyle/>
@@ -9797,11 +9797,11 @@
                 <a:spcPct val="100000"/>
               </a:lnSpc>
               <a:spcAft>
-                <a:spcPts val="100"/>
-              </a:spcAft>
-            </a:pPr>
-            <a:r>
-              <a:rPr sz="1300" b="0" i="0">
+                <a:spcPts val="0"/>
+              </a:spcAft>
+            </a:pPr>
+            <a:r>
+              <a:rPr sz="1200" b="0" i="0">
                 <a:solidFill>
                   <a:srgbClr val="64748B"/>
                 </a:solidFill>
@@ -9968,7 +9968,7 @@
         </p:blipFill>
         <p:spPr>
           <a:xfrm>
-            <a:off x="7237133" y="2513114"/>
+            <a:off x="7237133" y="2490254"/>
             <a:ext cx="3676573" cy="1127683"/>
           </a:xfrm>
           <a:prstGeom prst="rect">
@@ -10132,7 +10132,7 @@
         </p:blipFill>
         <p:spPr>
           <a:xfrm>
-            <a:off x="6766560" y="4541450"/>
+            <a:off x="6766560" y="4518590"/>
             <a:ext cx="4617720" cy="317130"/>
           </a:xfrm>
           <a:prstGeom prst="rect">
@@ -10296,7 +10296,7 @@
         </p:blipFill>
         <p:spPr>
           <a:xfrm>
-            <a:off x="7500023" y="5808726"/>
+            <a:off x="7500023" y="5785866"/>
             <a:ext cx="3150793" cy="342900"/>
           </a:xfrm>
           <a:prstGeom prst="rect">
@@ -10592,8 +10592,8 @@
         </p:nvSpPr>
         <p:spPr>
           <a:xfrm>
-            <a:off x="548640" y="1005840"/>
-            <a:ext cx="11155680" cy="1188720"/>
+            <a:off x="548640" y="987552"/>
+            <a:ext cx="8138160" cy="1280160"/>
           </a:xfrm>
           <a:prstGeom prst="roundRect">
             <a:avLst>
@@ -10646,8 +10646,8 @@
         </p:nvSpPr>
         <p:spPr>
           <a:xfrm>
-            <a:off x="548640" y="1115568"/>
-            <a:ext cx="64008" cy="969264"/>
+            <a:off x="548640" y="1097280"/>
+            <a:ext cx="64008" cy="1060704"/>
           </a:xfrm>
           <a:prstGeom prst="rect">
             <a:avLst/>
@@ -10690,8 +10690,8 @@
         </p:nvSpPr>
         <p:spPr>
           <a:xfrm>
-            <a:off x="777240" y="1097280"/>
-            <a:ext cx="10789919" cy="347472"/>
+            <a:off x="777240" y="1078992"/>
+            <a:ext cx="7772400" cy="347472"/>
           </a:xfrm>
           <a:prstGeom prst="rect">
             <a:avLst/>
@@ -10719,7 +10719,7 @@
                 </a:solidFill>
                 <a:latin typeface="Calibri"/>
               </a:rPr>
-              <a:t>DIRECT LIGHT + AMBIENT + EMISSION     (F: ILLUMINATION MODEL · ATT: FALLOFF · SH: SHADOW · N_L: NUMBER OF LIGHTS)</a:t>
+              <a:t>DIRECT LIGHT + AMBIENT + EMISSION</a:t>
             </a:r>
           </a:p>
         </p:txBody>
@@ -10740,8 +10740,8 @@
         </p:blipFill>
         <p:spPr>
           <a:xfrm>
-            <a:off x="3552097" y="1463040"/>
-            <a:ext cx="5148764" cy="621792"/>
+            <a:off x="1475459" y="1399032"/>
+            <a:ext cx="6284520" cy="758951"/>
           </a:xfrm>
           <a:prstGeom prst="rect">
             <a:avLst/>
@@ -10756,8 +10756,8 @@
         </p:nvSpPr>
         <p:spPr>
           <a:xfrm>
-            <a:off x="548640" y="2331720"/>
-            <a:ext cx="6400800" cy="4023360"/>
+            <a:off x="8823960" y="987552"/>
+            <a:ext cx="2880360" cy="1280160"/>
           </a:xfrm>
           <a:prstGeom prst="roundRect">
             <a:avLst>
@@ -10810,14 +10810,14 @@
         </p:nvSpPr>
         <p:spPr>
           <a:xfrm>
-            <a:off x="548640" y="2441448"/>
-            <a:ext cx="64008" cy="3803904"/>
+            <a:off x="8823960" y="1097280"/>
+            <a:ext cx="64008" cy="1060704"/>
           </a:xfrm>
           <a:prstGeom prst="rect">
             <a:avLst/>
           </a:prstGeom>
           <a:solidFill>
-            <a:srgbClr val="0F8F85"/>
+            <a:srgbClr val="F59E0B"/>
           </a:solidFill>
           <a:ln>
             <a:noFill/>
@@ -10854,8 +10854,8 @@
         </p:nvSpPr>
         <p:spPr>
           <a:xfrm>
-            <a:off x="777240" y="2450592"/>
-            <a:ext cx="1828800" cy="502920"/>
+            <a:off x="9052560" y="1078992"/>
+            <a:ext cx="2514600" cy="347472"/>
           </a:xfrm>
           <a:prstGeom prst="rect">
             <a:avLst/>
@@ -10863,7 +10863,7 @@
           <a:noFill/>
         </p:spPr>
         <p:txBody>
-          <a:bodyPr wrap="square" lIns="36576" rIns="36576" tIns="18288" bIns="18288" anchor="ctr">
+          <a:bodyPr wrap="square" lIns="36576" rIns="36576" tIns="18288" bIns="18288" anchor="t">
             <a:spAutoFit/>
           </a:bodyPr>
           <a:lstStyle/>
@@ -10877,95 +10877,27 @@
               </a:spcAft>
             </a:pPr>
             <a:r>
-              <a:rPr sz="1600" b="1" i="0">
+              <a:rPr sz="1200" b="1" i="0">
                 <a:solidFill>
                   <a:srgbClr val="0F8F85"/>
                 </a:solidFill>
                 <a:latin typeface="Calibri"/>
               </a:rPr>
-              <a:t>Lambert</a:t>
-            </a:r>
-          </a:p>
-        </p:txBody>
-      </p:sp>
-      <p:pic>
-        <p:nvPicPr>
-          <p:cNvPr id="16" name="Picture 15" descr="lambert.png"/>
-          <p:cNvPicPr>
-            <a:picLocks noChangeAspect="1"/>
-          </p:cNvPicPr>
-          <p:nvPr/>
-        </p:nvPicPr>
-        <p:blipFill>
-          <a:blip r:embed="rId5"/>
-          <a:stretch>
-            <a:fillRect/>
-          </a:stretch>
-        </p:blipFill>
-        <p:spPr>
-          <a:xfrm>
-            <a:off x="2606040" y="2441448"/>
-            <a:ext cx="725484" cy="481523"/>
-          </a:xfrm>
-          <a:prstGeom prst="rect">
-            <a:avLst/>
-          </a:prstGeom>
-        </p:spPr>
-      </p:pic>
-      <p:sp>
-        <p:nvSpPr>
-          <p:cNvPr id="17" name="Rectangle 16"/>
-          <p:cNvSpPr/>
-          <p:nvPr/>
-        </p:nvSpPr>
-        <p:spPr>
-          <a:xfrm>
-            <a:off x="777240" y="3026664"/>
-            <a:ext cx="5943600" cy="10972"/>
-          </a:xfrm>
-          <a:prstGeom prst="rect">
-            <a:avLst/>
-          </a:prstGeom>
-          <a:solidFill>
-            <a:srgbClr val="DDE5EE"/>
-          </a:solidFill>
-          <a:ln>
-            <a:noFill/>
-          </a:ln>
-          <a:effectLst/>
-        </p:spPr>
-        <p:style>
-          <a:lnRef idx="1">
-            <a:schemeClr val="accent1"/>
-          </a:lnRef>
-          <a:fillRef idx="3">
-            <a:schemeClr val="accent1"/>
-          </a:fillRef>
-          <a:effectRef idx="2">
-            <a:schemeClr val="accent1"/>
-          </a:effectRef>
-          <a:fontRef idx="minor">
-            <a:schemeClr val="lt1"/>
-          </a:fontRef>
-        </p:style>
-        <p:txBody>
-          <a:bodyPr rtlCol="0" anchor="ctr"/>
-          <a:lstStyle/>
-          <a:p>
-            <a:pPr algn="ctr"/>
-          </a:p>
-        </p:txBody>
-      </p:sp>
-      <p:sp>
-        <p:nvSpPr>
-          <p:cNvPr id="18" name="TextBox 17"/>
+              <a:t>SYMBOLS</a:t>
+            </a:r>
+          </a:p>
+        </p:txBody>
+      </p:sp>
+      <p:sp>
+        <p:nvSpPr>
+          <p:cNvPr id="16" name="TextBox 15"/>
           <p:cNvSpPr txBox="1"/>
           <p:nvPr/>
         </p:nvSpPr>
         <p:spPr>
           <a:xfrm>
-            <a:off x="777240" y="3099816"/>
-            <a:ext cx="1828800" cy="502920"/>
+            <a:off x="9052560" y="1371600"/>
+            <a:ext cx="2606040" cy="914400"/>
           </a:xfrm>
           <a:prstGeom prst="rect">
             <a:avLst/>
@@ -10973,7 +10905,7 @@
           <a:noFill/>
         </p:spPr>
         <p:txBody>
-          <a:bodyPr wrap="square" lIns="36576" rIns="36576" tIns="18288" bIns="18288" anchor="ctr">
+          <a:bodyPr wrap="square" lIns="36576" rIns="36576" tIns="18288" bIns="18288" anchor="t">
             <a:spAutoFit/>
           </a:bodyPr>
           <a:lstStyle/>
@@ -10983,495 +10915,88 @@
                 <a:spcPct val="100000"/>
               </a:lnSpc>
               <a:spcAft>
-                <a:spcPts val="400"/>
-              </a:spcAft>
-            </a:pPr>
-            <a:r>
-              <a:rPr sz="1600" b="1" i="0">
-                <a:solidFill>
-                  <a:srgbClr val="0F8F85"/>
-                </a:solidFill>
-                <a:latin typeface="Calibri"/>
-              </a:rPr>
-              <a:t>Phong</a:t>
-            </a:r>
-          </a:p>
-        </p:txBody>
-      </p:sp>
-      <p:pic>
-        <p:nvPicPr>
-          <p:cNvPr id="19" name="Picture 18" descr="phong.png"/>
-          <p:cNvPicPr>
-            <a:picLocks noChangeAspect="1"/>
-          </p:cNvPicPr>
-          <p:nvPr/>
-        </p:nvPicPr>
-        <p:blipFill>
-          <a:blip r:embed="rId6"/>
-          <a:stretch>
-            <a:fillRect/>
-          </a:stretch>
-        </p:blipFill>
-        <p:spPr>
-          <a:xfrm>
-            <a:off x="2606040" y="3090672"/>
-            <a:ext cx="3630989" cy="548640"/>
-          </a:xfrm>
-          <a:prstGeom prst="rect">
-            <a:avLst/>
-          </a:prstGeom>
-        </p:spPr>
-      </p:pic>
-      <p:sp>
-        <p:nvSpPr>
-          <p:cNvPr id="20" name="Rectangle 19"/>
+                <a:spcPts val="0"/>
+              </a:spcAft>
+            </a:pPr>
+            <a:r>
+              <a:rPr sz="1200" b="0" i="0">
+                <a:solidFill>
+                  <a:srgbClr val="64748B"/>
+                </a:solidFill>
+                <a:latin typeface="Calibri"/>
+              </a:rPr>
+              <a:t>f: illumination model</a:t>
+            </a:r>
+          </a:p>
+          <a:p>
+            <a:pPr algn="l">
+              <a:lnSpc>
+                <a:spcPct val="100000"/>
+              </a:lnSpc>
+              <a:spcAft>
+                <a:spcPts val="0"/>
+              </a:spcAft>
+            </a:pPr>
+            <a:r>
+              <a:rPr sz="1200" b="0" i="0">
+                <a:solidFill>
+                  <a:srgbClr val="64748B"/>
+                </a:solidFill>
+                <a:latin typeface="Calibri"/>
+              </a:rPr>
+              <a:t>att: falloff · sh: shadow</a:t>
+            </a:r>
+          </a:p>
+          <a:p>
+            <a:pPr algn="l">
+              <a:lnSpc>
+                <a:spcPct val="100000"/>
+              </a:lnSpc>
+              <a:spcAft>
+                <a:spcPts val="0"/>
+              </a:spcAft>
+            </a:pPr>
+            <a:r>
+              <a:rPr sz="1200" b="0" i="0">
+                <a:solidFill>
+                  <a:srgbClr val="64748B"/>
+                </a:solidFill>
+                <a:latin typeface="Calibri"/>
+              </a:rPr>
+              <a:t>N_L: lights · AO: occlusion</a:t>
+            </a:r>
+          </a:p>
+          <a:p>
+            <a:pPr algn="l">
+              <a:lnSpc>
+                <a:spcPct val="100000"/>
+              </a:lnSpc>
+              <a:spcAft>
+                <a:spcPts val="0"/>
+              </a:spcAft>
+            </a:pPr>
+            <a:r>
+              <a:rPr sz="1200" b="0" i="0">
+                <a:solidFill>
+                  <a:srgbClr val="64748B"/>
+                </a:solidFill>
+                <a:latin typeface="Calibri"/>
+              </a:rPr>
+              <a:t>e: emission</a:t>
+            </a:r>
+          </a:p>
+        </p:txBody>
+      </p:sp>
+      <p:sp>
+        <p:nvSpPr>
+          <p:cNvPr id="17" name="Rounded Rectangle 16"/>
           <p:cNvSpPr/>
           <p:nvPr/>
         </p:nvSpPr>
         <p:spPr>
           <a:xfrm>
-            <a:off x="777240" y="3675887"/>
-            <a:ext cx="5943600" cy="10972"/>
-          </a:xfrm>
-          <a:prstGeom prst="rect">
-            <a:avLst/>
-          </a:prstGeom>
-          <a:solidFill>
-            <a:srgbClr val="DDE5EE"/>
-          </a:solidFill>
-          <a:ln>
-            <a:noFill/>
-          </a:ln>
-          <a:effectLst/>
-        </p:spPr>
-        <p:style>
-          <a:lnRef idx="1">
-            <a:schemeClr val="accent1"/>
-          </a:lnRef>
-          <a:fillRef idx="3">
-            <a:schemeClr val="accent1"/>
-          </a:fillRef>
-          <a:effectRef idx="2">
-            <a:schemeClr val="accent1"/>
-          </a:effectRef>
-          <a:fontRef idx="minor">
-            <a:schemeClr val="lt1"/>
-          </a:fontRef>
-        </p:style>
-        <p:txBody>
-          <a:bodyPr rtlCol="0" anchor="ctr"/>
-          <a:lstStyle/>
-          <a:p>
-            <a:pPr algn="ctr"/>
-          </a:p>
-        </p:txBody>
-      </p:sp>
-      <p:sp>
-        <p:nvSpPr>
-          <p:cNvPr id="21" name="TextBox 20"/>
-          <p:cNvSpPr txBox="1"/>
-          <p:nvPr/>
-        </p:nvSpPr>
-        <p:spPr>
-          <a:xfrm>
-            <a:off x="777240" y="3749039"/>
-            <a:ext cx="1828800" cy="502920"/>
-          </a:xfrm>
-          <a:prstGeom prst="rect">
-            <a:avLst/>
-          </a:prstGeom>
-          <a:noFill/>
-        </p:spPr>
-        <p:txBody>
-          <a:bodyPr wrap="square" lIns="36576" rIns="36576" tIns="18288" bIns="18288" anchor="ctr">
-            <a:spAutoFit/>
-          </a:bodyPr>
-          <a:lstStyle/>
-          <a:p>
-            <a:pPr algn="l">
-              <a:lnSpc>
-                <a:spcPct val="100000"/>
-              </a:lnSpc>
-              <a:spcAft>
-                <a:spcPts val="400"/>
-              </a:spcAft>
-            </a:pPr>
-            <a:r>
-              <a:rPr sz="1600" b="1" i="0">
-                <a:solidFill>
-                  <a:srgbClr val="0F8F85"/>
-                </a:solidFill>
-                <a:latin typeface="Calibri"/>
-              </a:rPr>
-              <a:t>Blinn–Phong</a:t>
-            </a:r>
-          </a:p>
-        </p:txBody>
-      </p:sp>
-      <p:pic>
-        <p:nvPicPr>
-          <p:cNvPr id="22" name="Picture 21" descr="blinn.png"/>
-          <p:cNvPicPr>
-            <a:picLocks noChangeAspect="1"/>
-          </p:cNvPicPr>
-          <p:nvPr/>
-        </p:nvPicPr>
-        <p:blipFill>
-          <a:blip r:embed="rId7"/>
-          <a:stretch>
-            <a:fillRect/>
-          </a:stretch>
-        </p:blipFill>
-        <p:spPr>
-          <a:xfrm>
-            <a:off x="2606040" y="3739896"/>
-            <a:ext cx="3676451" cy="548640"/>
-          </a:xfrm>
-          <a:prstGeom prst="rect">
-            <a:avLst/>
-          </a:prstGeom>
-        </p:spPr>
-      </p:pic>
-      <p:sp>
-        <p:nvSpPr>
-          <p:cNvPr id="23" name="Rectangle 22"/>
-          <p:cNvSpPr/>
-          <p:nvPr/>
-        </p:nvSpPr>
-        <p:spPr>
-          <a:xfrm>
-            <a:off x="777240" y="4325112"/>
-            <a:ext cx="5943600" cy="10972"/>
-          </a:xfrm>
-          <a:prstGeom prst="rect">
-            <a:avLst/>
-          </a:prstGeom>
-          <a:solidFill>
-            <a:srgbClr val="DDE5EE"/>
-          </a:solidFill>
-          <a:ln>
-            <a:noFill/>
-          </a:ln>
-          <a:effectLst/>
-        </p:spPr>
-        <p:style>
-          <a:lnRef idx="1">
-            <a:schemeClr val="accent1"/>
-          </a:lnRef>
-          <a:fillRef idx="3">
-            <a:schemeClr val="accent1"/>
-          </a:fillRef>
-          <a:effectRef idx="2">
-            <a:schemeClr val="accent1"/>
-          </a:effectRef>
-          <a:fontRef idx="minor">
-            <a:schemeClr val="lt1"/>
-          </a:fontRef>
-        </p:style>
-        <p:txBody>
-          <a:bodyPr rtlCol="0" anchor="ctr"/>
-          <a:lstStyle/>
-          <a:p>
-            <a:pPr algn="ctr"/>
-          </a:p>
-        </p:txBody>
-      </p:sp>
-      <p:sp>
-        <p:nvSpPr>
-          <p:cNvPr id="24" name="TextBox 23"/>
-          <p:cNvSpPr txBox="1"/>
-          <p:nvPr/>
-        </p:nvSpPr>
-        <p:spPr>
-          <a:xfrm>
-            <a:off x="777240" y="4398264"/>
-            <a:ext cx="1828800" cy="502920"/>
-          </a:xfrm>
-          <a:prstGeom prst="rect">
-            <a:avLst/>
-          </a:prstGeom>
-          <a:noFill/>
-        </p:spPr>
-        <p:txBody>
-          <a:bodyPr wrap="square" lIns="36576" rIns="36576" tIns="18288" bIns="18288" anchor="ctr">
-            <a:spAutoFit/>
-          </a:bodyPr>
-          <a:lstStyle/>
-          <a:p>
-            <a:pPr algn="l">
-              <a:lnSpc>
-                <a:spcPct val="100000"/>
-              </a:lnSpc>
-              <a:spcAft>
-                <a:spcPts val="400"/>
-              </a:spcAft>
-            </a:pPr>
-            <a:r>
-              <a:rPr sz="1600" b="1" i="0">
-                <a:solidFill>
-                  <a:srgbClr val="0F8F85"/>
-                </a:solidFill>
-                <a:latin typeface="Calibri"/>
-              </a:rPr>
-              <a:t>Oren–Nayar</a:t>
-            </a:r>
-          </a:p>
-        </p:txBody>
-      </p:sp>
-      <p:pic>
-        <p:nvPicPr>
-          <p:cNvPr id="25" name="Picture 24" descr="oren.png"/>
-          <p:cNvPicPr>
-            <a:picLocks noChangeAspect="1"/>
-          </p:cNvPicPr>
-          <p:nvPr/>
-        </p:nvPicPr>
-        <p:blipFill>
-          <a:blip r:embed="rId8"/>
-          <a:stretch>
-            <a:fillRect/>
-          </a:stretch>
-        </p:blipFill>
-        <p:spPr>
-          <a:xfrm>
-            <a:off x="2606040" y="4389120"/>
-            <a:ext cx="4206240" cy="463060"/>
-          </a:xfrm>
-          <a:prstGeom prst="rect">
-            <a:avLst/>
-          </a:prstGeom>
-        </p:spPr>
-      </p:pic>
-      <p:sp>
-        <p:nvSpPr>
-          <p:cNvPr id="26" name="Rectangle 25"/>
-          <p:cNvSpPr/>
-          <p:nvPr/>
-        </p:nvSpPr>
-        <p:spPr>
-          <a:xfrm>
-            <a:off x="777240" y="4974336"/>
-            <a:ext cx="5943600" cy="10972"/>
-          </a:xfrm>
-          <a:prstGeom prst="rect">
-            <a:avLst/>
-          </a:prstGeom>
-          <a:solidFill>
-            <a:srgbClr val="DDE5EE"/>
-          </a:solidFill>
-          <a:ln>
-            <a:noFill/>
-          </a:ln>
-          <a:effectLst/>
-        </p:spPr>
-        <p:style>
-          <a:lnRef idx="1">
-            <a:schemeClr val="accent1"/>
-          </a:lnRef>
-          <a:fillRef idx="3">
-            <a:schemeClr val="accent1"/>
-          </a:fillRef>
-          <a:effectRef idx="2">
-            <a:schemeClr val="accent1"/>
-          </a:effectRef>
-          <a:fontRef idx="minor">
-            <a:schemeClr val="lt1"/>
-          </a:fontRef>
-        </p:style>
-        <p:txBody>
-          <a:bodyPr rtlCol="0" anchor="ctr"/>
-          <a:lstStyle/>
-          <a:p>
-            <a:pPr algn="ctr"/>
-          </a:p>
-        </p:txBody>
-      </p:sp>
-      <p:sp>
-        <p:nvSpPr>
-          <p:cNvPr id="27" name="TextBox 26"/>
-          <p:cNvSpPr txBox="1"/>
-          <p:nvPr/>
-        </p:nvSpPr>
-        <p:spPr>
-          <a:xfrm>
-            <a:off x="777240" y="5047488"/>
-            <a:ext cx="1828800" cy="502920"/>
-          </a:xfrm>
-          <a:prstGeom prst="rect">
-            <a:avLst/>
-          </a:prstGeom>
-          <a:noFill/>
-        </p:spPr>
-        <p:txBody>
-          <a:bodyPr wrap="square" lIns="36576" rIns="36576" tIns="18288" bIns="18288" anchor="ctr">
-            <a:spAutoFit/>
-          </a:bodyPr>
-          <a:lstStyle/>
-          <a:p>
-            <a:pPr algn="l">
-              <a:lnSpc>
-                <a:spcPct val="100000"/>
-              </a:lnSpc>
-              <a:spcAft>
-                <a:spcPts val="400"/>
-              </a:spcAft>
-            </a:pPr>
-            <a:r>
-              <a:rPr sz="1600" b="1" i="0">
-                <a:solidFill>
-                  <a:srgbClr val="0F8F85"/>
-                </a:solidFill>
-                <a:latin typeface="Calibri"/>
-              </a:rPr>
-              <a:t>Cook–Torrance</a:t>
-            </a:r>
-          </a:p>
-        </p:txBody>
-      </p:sp>
-      <p:pic>
-        <p:nvPicPr>
-          <p:cNvPr id="28" name="Picture 27" descr="ct2.png"/>
-          <p:cNvPicPr>
-            <a:picLocks noChangeAspect="1"/>
-          </p:cNvPicPr>
-          <p:nvPr/>
-        </p:nvPicPr>
-        <p:blipFill>
-          <a:blip r:embed="rId9"/>
-          <a:stretch>
-            <a:fillRect/>
-          </a:stretch>
-        </p:blipFill>
-        <p:spPr>
-          <a:xfrm>
-            <a:off x="2606040" y="5038344"/>
-            <a:ext cx="3255106" cy="548640"/>
-          </a:xfrm>
-          <a:prstGeom prst="rect">
-            <a:avLst/>
-          </a:prstGeom>
-        </p:spPr>
-      </p:pic>
-      <p:sp>
-        <p:nvSpPr>
-          <p:cNvPr id="29" name="Rectangle 28"/>
-          <p:cNvSpPr/>
-          <p:nvPr/>
-        </p:nvSpPr>
-        <p:spPr>
-          <a:xfrm>
-            <a:off x="777240" y="5623560"/>
-            <a:ext cx="5943600" cy="10972"/>
-          </a:xfrm>
-          <a:prstGeom prst="rect">
-            <a:avLst/>
-          </a:prstGeom>
-          <a:solidFill>
-            <a:srgbClr val="DDE5EE"/>
-          </a:solidFill>
-          <a:ln>
-            <a:noFill/>
-          </a:ln>
-          <a:effectLst/>
-        </p:spPr>
-        <p:style>
-          <a:lnRef idx="1">
-            <a:schemeClr val="accent1"/>
-          </a:lnRef>
-          <a:fillRef idx="3">
-            <a:schemeClr val="accent1"/>
-          </a:fillRef>
-          <a:effectRef idx="2">
-            <a:schemeClr val="accent1"/>
-          </a:effectRef>
-          <a:fontRef idx="minor">
-            <a:schemeClr val="lt1"/>
-          </a:fontRef>
-        </p:style>
-        <p:txBody>
-          <a:bodyPr rtlCol="0" anchor="ctr"/>
-          <a:lstStyle/>
-          <a:p>
-            <a:pPr algn="ctr"/>
-          </a:p>
-        </p:txBody>
-      </p:sp>
-      <p:sp>
-        <p:nvSpPr>
-          <p:cNvPr id="30" name="TextBox 29"/>
-          <p:cNvSpPr txBox="1"/>
-          <p:nvPr/>
-        </p:nvSpPr>
-        <p:spPr>
-          <a:xfrm>
-            <a:off x="777240" y="5696712"/>
-            <a:ext cx="1828800" cy="502920"/>
-          </a:xfrm>
-          <a:prstGeom prst="rect">
-            <a:avLst/>
-          </a:prstGeom>
-          <a:noFill/>
-        </p:spPr>
-        <p:txBody>
-          <a:bodyPr wrap="square" lIns="36576" rIns="36576" tIns="18288" bIns="18288" anchor="ctr">
-            <a:spAutoFit/>
-          </a:bodyPr>
-          <a:lstStyle/>
-          <a:p>
-            <a:pPr algn="l">
-              <a:lnSpc>
-                <a:spcPct val="100000"/>
-              </a:lnSpc>
-              <a:spcAft>
-                <a:spcPts val="400"/>
-              </a:spcAft>
-            </a:pPr>
-            <a:r>
-              <a:rPr sz="1600" b="1" i="0">
-                <a:solidFill>
-                  <a:srgbClr val="0F8F85"/>
-                </a:solidFill>
-                <a:latin typeface="Calibri"/>
-              </a:rPr>
-              <a:t>Subsurface</a:t>
-            </a:r>
-          </a:p>
-        </p:txBody>
-      </p:sp>
-      <p:pic>
-        <p:nvPicPr>
-          <p:cNvPr id="31" name="Picture 30" descr="sss.png"/>
-          <p:cNvPicPr>
-            <a:picLocks noChangeAspect="1"/>
-          </p:cNvPicPr>
-          <p:nvPr/>
-        </p:nvPicPr>
-        <p:blipFill>
-          <a:blip r:embed="rId10"/>
-          <a:stretch>
-            <a:fillRect/>
-          </a:stretch>
-        </p:blipFill>
-        <p:spPr>
-          <a:xfrm>
-            <a:off x="2606040" y="5687568"/>
-            <a:ext cx="3843144" cy="548640"/>
-          </a:xfrm>
-          <a:prstGeom prst="rect">
-            <a:avLst/>
-          </a:prstGeom>
-        </p:spPr>
-      </p:pic>
-      <p:sp>
-        <p:nvSpPr>
-          <p:cNvPr id="32" name="Rounded Rectangle 31"/>
-          <p:cNvSpPr/>
-          <p:nvPr/>
-        </p:nvSpPr>
-        <p:spPr>
-          <a:xfrm>
-            <a:off x="7223760" y="2331720"/>
-            <a:ext cx="4480560" cy="1600200"/>
+            <a:off x="548640" y="2331720"/>
+            <a:ext cx="6400800" cy="4023360"/>
           </a:xfrm>
           <a:prstGeom prst="roundRect">
             <a:avLst>
@@ -11518,14 +11043,14 @@
       </p:sp>
       <p:sp>
         <p:nvSpPr>
-          <p:cNvPr id="33" name="Rectangle 32"/>
+          <p:cNvPr id="18" name="Rectangle 17"/>
           <p:cNvSpPr/>
           <p:nvPr/>
         </p:nvSpPr>
         <p:spPr>
           <a:xfrm>
-            <a:off x="7223760" y="2441448"/>
-            <a:ext cx="64008" cy="1380744"/>
+            <a:off x="548640" y="2441448"/>
+            <a:ext cx="64008" cy="3803904"/>
           </a:xfrm>
           <a:prstGeom prst="rect">
             <a:avLst/>
@@ -11562,14 +11087,14 @@
       </p:sp>
       <p:sp>
         <p:nvSpPr>
-          <p:cNvPr id="34" name="TextBox 33"/>
+          <p:cNvPr id="19" name="TextBox 18"/>
           <p:cNvSpPr txBox="1"/>
           <p:nvPr/>
         </p:nvSpPr>
         <p:spPr>
           <a:xfrm>
-            <a:off x="7452360" y="2423160"/>
-            <a:ext cx="4114800" cy="347472"/>
+            <a:off x="777240" y="2450592"/>
+            <a:ext cx="1828800" cy="502920"/>
           </a:xfrm>
           <a:prstGeom prst="rect">
             <a:avLst/>
@@ -11577,7 +11102,7 @@
           <a:noFill/>
         </p:spPr>
         <p:txBody>
-          <a:bodyPr wrap="square" lIns="36576" rIns="36576" tIns="18288" bIns="18288" anchor="t">
+          <a:bodyPr wrap="square" lIns="36576" rIns="36576" tIns="18288" bIns="18288" anchor="ctr">
             <a:spAutoFit/>
           </a:bodyPr>
           <a:lstStyle/>
@@ -11591,77 +11116,35 @@
               </a:spcAft>
             </a:pPr>
             <a:r>
-              <a:rPr sz="1200" b="1" i="0">
+              <a:rPr sz="1600" b="1" i="0">
                 <a:solidFill>
                   <a:srgbClr val="0F8F85"/>
                 </a:solidFill>
                 <a:latin typeface="Calibri"/>
               </a:rPr>
-              <a:t>LIGHT SOURCES</a:t>
-            </a:r>
-          </a:p>
-        </p:txBody>
-      </p:sp>
-      <p:sp>
-        <p:nvSpPr>
-          <p:cNvPr id="35" name="TextBox 34"/>
-          <p:cNvSpPr txBox="1"/>
-          <p:nvPr/>
-        </p:nvSpPr>
-        <p:spPr>
-          <a:xfrm>
-            <a:off x="7452360" y="2697480"/>
-            <a:ext cx="4114800" cy="365760"/>
-          </a:xfrm>
-          <a:prstGeom prst="rect">
-            <a:avLst/>
-          </a:prstGeom>
-          <a:noFill/>
-        </p:spPr>
-        <p:txBody>
-          <a:bodyPr wrap="square" lIns="36576" rIns="36576" tIns="18288" bIns="18288" anchor="t">
-            <a:spAutoFit/>
-          </a:bodyPr>
-          <a:lstStyle/>
-          <a:p>
-            <a:pPr algn="l">
-              <a:lnSpc>
-                <a:spcPct val="100000"/>
-              </a:lnSpc>
-              <a:spcAft>
-                <a:spcPts val="400"/>
-              </a:spcAft>
-            </a:pPr>
-            <a:r>
-              <a:rPr sz="1300" b="0" i="0">
-                <a:solidFill>
-                  <a:srgbClr val="64748B"/>
-                </a:solidFill>
-                <a:latin typeface="Calibri"/>
-              </a:rPr>
-              <a:t>Directional · Point · Spot · Area (4×4 samples)</a:t>
+              <a:t>Lambert</a:t>
             </a:r>
           </a:p>
         </p:txBody>
       </p:sp>
       <p:pic>
         <p:nvPicPr>
-          <p:cNvPr id="36" name="Picture 35" descr="att.png"/>
+          <p:cNvPr id="20" name="Picture 19" descr="lambert.png"/>
           <p:cNvPicPr>
             <a:picLocks noChangeAspect="1"/>
           </p:cNvPicPr>
           <p:nvPr/>
         </p:nvPicPr>
         <p:blipFill>
-          <a:blip r:embed="rId11"/>
+          <a:blip r:embed="rId5"/>
           <a:stretch>
             <a:fillRect/>
           </a:stretch>
         </p:blipFill>
         <p:spPr>
           <a:xfrm>
-            <a:off x="7976516" y="3017520"/>
-            <a:ext cx="2975046" cy="868680"/>
+            <a:off x="2606040" y="2441448"/>
+            <a:ext cx="725484" cy="481523"/>
           </a:xfrm>
           <a:prstGeom prst="rect">
             <a:avLst/>
@@ -11670,14 +11153,564 @@
       </p:pic>
       <p:sp>
         <p:nvSpPr>
-          <p:cNvPr id="37" name="Rounded Rectangle 36"/>
+          <p:cNvPr id="21" name="Rectangle 20"/>
           <p:cNvSpPr/>
           <p:nvPr/>
         </p:nvSpPr>
         <p:spPr>
           <a:xfrm>
-            <a:off x="7223760" y="4069080"/>
-            <a:ext cx="4480560" cy="2286000"/>
+            <a:off x="777240" y="3026664"/>
+            <a:ext cx="5943600" cy="10972"/>
+          </a:xfrm>
+          <a:prstGeom prst="rect">
+            <a:avLst/>
+          </a:prstGeom>
+          <a:solidFill>
+            <a:srgbClr val="DDE5EE"/>
+          </a:solidFill>
+          <a:ln>
+            <a:noFill/>
+          </a:ln>
+          <a:effectLst/>
+        </p:spPr>
+        <p:style>
+          <a:lnRef idx="1">
+            <a:schemeClr val="accent1"/>
+          </a:lnRef>
+          <a:fillRef idx="3">
+            <a:schemeClr val="accent1"/>
+          </a:fillRef>
+          <a:effectRef idx="2">
+            <a:schemeClr val="accent1"/>
+          </a:effectRef>
+          <a:fontRef idx="minor">
+            <a:schemeClr val="lt1"/>
+          </a:fontRef>
+        </p:style>
+        <p:txBody>
+          <a:bodyPr rtlCol="0" anchor="ctr"/>
+          <a:lstStyle/>
+          <a:p>
+            <a:pPr algn="ctr"/>
+          </a:p>
+        </p:txBody>
+      </p:sp>
+      <p:sp>
+        <p:nvSpPr>
+          <p:cNvPr id="22" name="TextBox 21"/>
+          <p:cNvSpPr txBox="1"/>
+          <p:nvPr/>
+        </p:nvSpPr>
+        <p:spPr>
+          <a:xfrm>
+            <a:off x="777240" y="3099816"/>
+            <a:ext cx="1828800" cy="502920"/>
+          </a:xfrm>
+          <a:prstGeom prst="rect">
+            <a:avLst/>
+          </a:prstGeom>
+          <a:noFill/>
+        </p:spPr>
+        <p:txBody>
+          <a:bodyPr wrap="square" lIns="36576" rIns="36576" tIns="18288" bIns="18288" anchor="ctr">
+            <a:spAutoFit/>
+          </a:bodyPr>
+          <a:lstStyle/>
+          <a:p>
+            <a:pPr algn="l">
+              <a:lnSpc>
+                <a:spcPct val="100000"/>
+              </a:lnSpc>
+              <a:spcAft>
+                <a:spcPts val="400"/>
+              </a:spcAft>
+            </a:pPr>
+            <a:r>
+              <a:rPr sz="1600" b="1" i="0">
+                <a:solidFill>
+                  <a:srgbClr val="0F8F85"/>
+                </a:solidFill>
+                <a:latin typeface="Calibri"/>
+              </a:rPr>
+              <a:t>Phong</a:t>
+            </a:r>
+          </a:p>
+        </p:txBody>
+      </p:sp>
+      <p:pic>
+        <p:nvPicPr>
+          <p:cNvPr id="23" name="Picture 22" descr="phong.png"/>
+          <p:cNvPicPr>
+            <a:picLocks noChangeAspect="1"/>
+          </p:cNvPicPr>
+          <p:nvPr/>
+        </p:nvPicPr>
+        <p:blipFill>
+          <a:blip r:embed="rId6"/>
+          <a:stretch>
+            <a:fillRect/>
+          </a:stretch>
+        </p:blipFill>
+        <p:spPr>
+          <a:xfrm>
+            <a:off x="2606040" y="3090672"/>
+            <a:ext cx="3630989" cy="548640"/>
+          </a:xfrm>
+          <a:prstGeom prst="rect">
+            <a:avLst/>
+          </a:prstGeom>
+        </p:spPr>
+      </p:pic>
+      <p:sp>
+        <p:nvSpPr>
+          <p:cNvPr id="24" name="Rectangle 23"/>
+          <p:cNvSpPr/>
+          <p:nvPr/>
+        </p:nvSpPr>
+        <p:spPr>
+          <a:xfrm>
+            <a:off x="777240" y="3675887"/>
+            <a:ext cx="5943600" cy="10972"/>
+          </a:xfrm>
+          <a:prstGeom prst="rect">
+            <a:avLst/>
+          </a:prstGeom>
+          <a:solidFill>
+            <a:srgbClr val="DDE5EE"/>
+          </a:solidFill>
+          <a:ln>
+            <a:noFill/>
+          </a:ln>
+          <a:effectLst/>
+        </p:spPr>
+        <p:style>
+          <a:lnRef idx="1">
+            <a:schemeClr val="accent1"/>
+          </a:lnRef>
+          <a:fillRef idx="3">
+            <a:schemeClr val="accent1"/>
+          </a:fillRef>
+          <a:effectRef idx="2">
+            <a:schemeClr val="accent1"/>
+          </a:effectRef>
+          <a:fontRef idx="minor">
+            <a:schemeClr val="lt1"/>
+          </a:fontRef>
+        </p:style>
+        <p:txBody>
+          <a:bodyPr rtlCol="0" anchor="ctr"/>
+          <a:lstStyle/>
+          <a:p>
+            <a:pPr algn="ctr"/>
+          </a:p>
+        </p:txBody>
+      </p:sp>
+      <p:sp>
+        <p:nvSpPr>
+          <p:cNvPr id="25" name="TextBox 24"/>
+          <p:cNvSpPr txBox="1"/>
+          <p:nvPr/>
+        </p:nvSpPr>
+        <p:spPr>
+          <a:xfrm>
+            <a:off x="777240" y="3749039"/>
+            <a:ext cx="1828800" cy="502920"/>
+          </a:xfrm>
+          <a:prstGeom prst="rect">
+            <a:avLst/>
+          </a:prstGeom>
+          <a:noFill/>
+        </p:spPr>
+        <p:txBody>
+          <a:bodyPr wrap="square" lIns="36576" rIns="36576" tIns="18288" bIns="18288" anchor="ctr">
+            <a:spAutoFit/>
+          </a:bodyPr>
+          <a:lstStyle/>
+          <a:p>
+            <a:pPr algn="l">
+              <a:lnSpc>
+                <a:spcPct val="100000"/>
+              </a:lnSpc>
+              <a:spcAft>
+                <a:spcPts val="400"/>
+              </a:spcAft>
+            </a:pPr>
+            <a:r>
+              <a:rPr sz="1600" b="1" i="0">
+                <a:solidFill>
+                  <a:srgbClr val="0F8F85"/>
+                </a:solidFill>
+                <a:latin typeface="Calibri"/>
+              </a:rPr>
+              <a:t>Blinn–Phong</a:t>
+            </a:r>
+          </a:p>
+        </p:txBody>
+      </p:sp>
+      <p:pic>
+        <p:nvPicPr>
+          <p:cNvPr id="26" name="Picture 25" descr="blinn.png"/>
+          <p:cNvPicPr>
+            <a:picLocks noChangeAspect="1"/>
+          </p:cNvPicPr>
+          <p:nvPr/>
+        </p:nvPicPr>
+        <p:blipFill>
+          <a:blip r:embed="rId7"/>
+          <a:stretch>
+            <a:fillRect/>
+          </a:stretch>
+        </p:blipFill>
+        <p:spPr>
+          <a:xfrm>
+            <a:off x="2606040" y="3739896"/>
+            <a:ext cx="3676451" cy="548640"/>
+          </a:xfrm>
+          <a:prstGeom prst="rect">
+            <a:avLst/>
+          </a:prstGeom>
+        </p:spPr>
+      </p:pic>
+      <p:sp>
+        <p:nvSpPr>
+          <p:cNvPr id="27" name="Rectangle 26"/>
+          <p:cNvSpPr/>
+          <p:nvPr/>
+        </p:nvSpPr>
+        <p:spPr>
+          <a:xfrm>
+            <a:off x="777240" y="4325112"/>
+            <a:ext cx="5943600" cy="10972"/>
+          </a:xfrm>
+          <a:prstGeom prst="rect">
+            <a:avLst/>
+          </a:prstGeom>
+          <a:solidFill>
+            <a:srgbClr val="DDE5EE"/>
+          </a:solidFill>
+          <a:ln>
+            <a:noFill/>
+          </a:ln>
+          <a:effectLst/>
+        </p:spPr>
+        <p:style>
+          <a:lnRef idx="1">
+            <a:schemeClr val="accent1"/>
+          </a:lnRef>
+          <a:fillRef idx="3">
+            <a:schemeClr val="accent1"/>
+          </a:fillRef>
+          <a:effectRef idx="2">
+            <a:schemeClr val="accent1"/>
+          </a:effectRef>
+          <a:fontRef idx="minor">
+            <a:schemeClr val="lt1"/>
+          </a:fontRef>
+        </p:style>
+        <p:txBody>
+          <a:bodyPr rtlCol="0" anchor="ctr"/>
+          <a:lstStyle/>
+          <a:p>
+            <a:pPr algn="ctr"/>
+          </a:p>
+        </p:txBody>
+      </p:sp>
+      <p:sp>
+        <p:nvSpPr>
+          <p:cNvPr id="28" name="TextBox 27"/>
+          <p:cNvSpPr txBox="1"/>
+          <p:nvPr/>
+        </p:nvSpPr>
+        <p:spPr>
+          <a:xfrm>
+            <a:off x="777240" y="4398264"/>
+            <a:ext cx="1828800" cy="502920"/>
+          </a:xfrm>
+          <a:prstGeom prst="rect">
+            <a:avLst/>
+          </a:prstGeom>
+          <a:noFill/>
+        </p:spPr>
+        <p:txBody>
+          <a:bodyPr wrap="square" lIns="36576" rIns="36576" tIns="18288" bIns="18288" anchor="ctr">
+            <a:spAutoFit/>
+          </a:bodyPr>
+          <a:lstStyle/>
+          <a:p>
+            <a:pPr algn="l">
+              <a:lnSpc>
+                <a:spcPct val="100000"/>
+              </a:lnSpc>
+              <a:spcAft>
+                <a:spcPts val="400"/>
+              </a:spcAft>
+            </a:pPr>
+            <a:r>
+              <a:rPr sz="1600" b="1" i="0">
+                <a:solidFill>
+                  <a:srgbClr val="0F8F85"/>
+                </a:solidFill>
+                <a:latin typeface="Calibri"/>
+              </a:rPr>
+              <a:t>Oren–Nayar</a:t>
+            </a:r>
+          </a:p>
+        </p:txBody>
+      </p:sp>
+      <p:pic>
+        <p:nvPicPr>
+          <p:cNvPr id="29" name="Picture 28" descr="oren.png"/>
+          <p:cNvPicPr>
+            <a:picLocks noChangeAspect="1"/>
+          </p:cNvPicPr>
+          <p:nvPr/>
+        </p:nvPicPr>
+        <p:blipFill>
+          <a:blip r:embed="rId8"/>
+          <a:stretch>
+            <a:fillRect/>
+          </a:stretch>
+        </p:blipFill>
+        <p:spPr>
+          <a:xfrm>
+            <a:off x="2606040" y="4389120"/>
+            <a:ext cx="4206240" cy="463060"/>
+          </a:xfrm>
+          <a:prstGeom prst="rect">
+            <a:avLst/>
+          </a:prstGeom>
+        </p:spPr>
+      </p:pic>
+      <p:sp>
+        <p:nvSpPr>
+          <p:cNvPr id="30" name="Rectangle 29"/>
+          <p:cNvSpPr/>
+          <p:nvPr/>
+        </p:nvSpPr>
+        <p:spPr>
+          <a:xfrm>
+            <a:off x="777240" y="4974336"/>
+            <a:ext cx="5943600" cy="10972"/>
+          </a:xfrm>
+          <a:prstGeom prst="rect">
+            <a:avLst/>
+          </a:prstGeom>
+          <a:solidFill>
+            <a:srgbClr val="DDE5EE"/>
+          </a:solidFill>
+          <a:ln>
+            <a:noFill/>
+          </a:ln>
+          <a:effectLst/>
+        </p:spPr>
+        <p:style>
+          <a:lnRef idx="1">
+            <a:schemeClr val="accent1"/>
+          </a:lnRef>
+          <a:fillRef idx="3">
+            <a:schemeClr val="accent1"/>
+          </a:fillRef>
+          <a:effectRef idx="2">
+            <a:schemeClr val="accent1"/>
+          </a:effectRef>
+          <a:fontRef idx="minor">
+            <a:schemeClr val="lt1"/>
+          </a:fontRef>
+        </p:style>
+        <p:txBody>
+          <a:bodyPr rtlCol="0" anchor="ctr"/>
+          <a:lstStyle/>
+          <a:p>
+            <a:pPr algn="ctr"/>
+          </a:p>
+        </p:txBody>
+      </p:sp>
+      <p:sp>
+        <p:nvSpPr>
+          <p:cNvPr id="31" name="TextBox 30"/>
+          <p:cNvSpPr txBox="1"/>
+          <p:nvPr/>
+        </p:nvSpPr>
+        <p:spPr>
+          <a:xfrm>
+            <a:off x="777240" y="5047488"/>
+            <a:ext cx="1828800" cy="502920"/>
+          </a:xfrm>
+          <a:prstGeom prst="rect">
+            <a:avLst/>
+          </a:prstGeom>
+          <a:noFill/>
+        </p:spPr>
+        <p:txBody>
+          <a:bodyPr wrap="square" lIns="36576" rIns="36576" tIns="18288" bIns="18288" anchor="ctr">
+            <a:spAutoFit/>
+          </a:bodyPr>
+          <a:lstStyle/>
+          <a:p>
+            <a:pPr algn="l">
+              <a:lnSpc>
+                <a:spcPct val="100000"/>
+              </a:lnSpc>
+              <a:spcAft>
+                <a:spcPts val="400"/>
+              </a:spcAft>
+            </a:pPr>
+            <a:r>
+              <a:rPr sz="1600" b="1" i="0">
+                <a:solidFill>
+                  <a:srgbClr val="0F8F85"/>
+                </a:solidFill>
+                <a:latin typeface="Calibri"/>
+              </a:rPr>
+              <a:t>Cook–Torrance</a:t>
+            </a:r>
+          </a:p>
+        </p:txBody>
+      </p:sp>
+      <p:pic>
+        <p:nvPicPr>
+          <p:cNvPr id="32" name="Picture 31" descr="ct2.png"/>
+          <p:cNvPicPr>
+            <a:picLocks noChangeAspect="1"/>
+          </p:cNvPicPr>
+          <p:nvPr/>
+        </p:nvPicPr>
+        <p:blipFill>
+          <a:blip r:embed="rId9"/>
+          <a:stretch>
+            <a:fillRect/>
+          </a:stretch>
+        </p:blipFill>
+        <p:spPr>
+          <a:xfrm>
+            <a:off x="2606040" y="5038344"/>
+            <a:ext cx="3255106" cy="548640"/>
+          </a:xfrm>
+          <a:prstGeom prst="rect">
+            <a:avLst/>
+          </a:prstGeom>
+        </p:spPr>
+      </p:pic>
+      <p:sp>
+        <p:nvSpPr>
+          <p:cNvPr id="33" name="Rectangle 32"/>
+          <p:cNvSpPr/>
+          <p:nvPr/>
+        </p:nvSpPr>
+        <p:spPr>
+          <a:xfrm>
+            <a:off x="777240" y="5623560"/>
+            <a:ext cx="5943600" cy="10972"/>
+          </a:xfrm>
+          <a:prstGeom prst="rect">
+            <a:avLst/>
+          </a:prstGeom>
+          <a:solidFill>
+            <a:srgbClr val="DDE5EE"/>
+          </a:solidFill>
+          <a:ln>
+            <a:noFill/>
+          </a:ln>
+          <a:effectLst/>
+        </p:spPr>
+        <p:style>
+          <a:lnRef idx="1">
+            <a:schemeClr val="accent1"/>
+          </a:lnRef>
+          <a:fillRef idx="3">
+            <a:schemeClr val="accent1"/>
+          </a:fillRef>
+          <a:effectRef idx="2">
+            <a:schemeClr val="accent1"/>
+          </a:effectRef>
+          <a:fontRef idx="minor">
+            <a:schemeClr val="lt1"/>
+          </a:fontRef>
+        </p:style>
+        <p:txBody>
+          <a:bodyPr rtlCol="0" anchor="ctr"/>
+          <a:lstStyle/>
+          <a:p>
+            <a:pPr algn="ctr"/>
+          </a:p>
+        </p:txBody>
+      </p:sp>
+      <p:sp>
+        <p:nvSpPr>
+          <p:cNvPr id="34" name="TextBox 33"/>
+          <p:cNvSpPr txBox="1"/>
+          <p:nvPr/>
+        </p:nvSpPr>
+        <p:spPr>
+          <a:xfrm>
+            <a:off x="777240" y="5696712"/>
+            <a:ext cx="1828800" cy="502920"/>
+          </a:xfrm>
+          <a:prstGeom prst="rect">
+            <a:avLst/>
+          </a:prstGeom>
+          <a:noFill/>
+        </p:spPr>
+        <p:txBody>
+          <a:bodyPr wrap="square" lIns="36576" rIns="36576" tIns="18288" bIns="18288" anchor="ctr">
+            <a:spAutoFit/>
+          </a:bodyPr>
+          <a:lstStyle/>
+          <a:p>
+            <a:pPr algn="l">
+              <a:lnSpc>
+                <a:spcPct val="100000"/>
+              </a:lnSpc>
+              <a:spcAft>
+                <a:spcPts val="400"/>
+              </a:spcAft>
+            </a:pPr>
+            <a:r>
+              <a:rPr sz="1600" b="1" i="0">
+                <a:solidFill>
+                  <a:srgbClr val="0F8F85"/>
+                </a:solidFill>
+                <a:latin typeface="Calibri"/>
+              </a:rPr>
+              <a:t>Subsurface</a:t>
+            </a:r>
+          </a:p>
+        </p:txBody>
+      </p:sp>
+      <p:pic>
+        <p:nvPicPr>
+          <p:cNvPr id="35" name="Picture 34" descr="sss.png"/>
+          <p:cNvPicPr>
+            <a:picLocks noChangeAspect="1"/>
+          </p:cNvPicPr>
+          <p:nvPr/>
+        </p:nvPicPr>
+        <p:blipFill>
+          <a:blip r:embed="rId10"/>
+          <a:stretch>
+            <a:fillRect/>
+          </a:stretch>
+        </p:blipFill>
+        <p:spPr>
+          <a:xfrm>
+            <a:off x="2606040" y="5687568"/>
+            <a:ext cx="3843144" cy="548640"/>
+          </a:xfrm>
+          <a:prstGeom prst="rect">
+            <a:avLst/>
+          </a:prstGeom>
+        </p:spPr>
+      </p:pic>
+      <p:sp>
+        <p:nvSpPr>
+          <p:cNvPr id="36" name="Rounded Rectangle 35"/>
+          <p:cNvSpPr/>
+          <p:nvPr/>
+        </p:nvSpPr>
+        <p:spPr>
+          <a:xfrm>
+            <a:off x="7223760" y="2331720"/>
+            <a:ext cx="4480560" cy="1600200"/>
           </a:xfrm>
           <a:prstGeom prst="roundRect">
             <a:avLst>
@@ -11724,14 +11757,14 @@
       </p:sp>
       <p:sp>
         <p:nvSpPr>
-          <p:cNvPr id="38" name="Rectangle 37"/>
+          <p:cNvPr id="37" name="Rectangle 36"/>
           <p:cNvSpPr/>
           <p:nvPr/>
         </p:nvSpPr>
         <p:spPr>
           <a:xfrm>
-            <a:off x="7223760" y="4178808"/>
-            <a:ext cx="64008" cy="2066543"/>
+            <a:off x="7223760" y="2441448"/>
+            <a:ext cx="64008" cy="1380744"/>
           </a:xfrm>
           <a:prstGeom prst="rect">
             <a:avLst/>
@@ -11768,13 +11801,13 @@
       </p:sp>
       <p:sp>
         <p:nvSpPr>
-          <p:cNvPr id="39" name="TextBox 38"/>
+          <p:cNvPr id="38" name="TextBox 37"/>
           <p:cNvSpPr txBox="1"/>
           <p:nvPr/>
         </p:nvSpPr>
         <p:spPr>
           <a:xfrm>
-            <a:off x="7452360" y="4160520"/>
+            <a:off x="7452360" y="2423160"/>
             <a:ext cx="4114800" cy="347472"/>
           </a:xfrm>
           <a:prstGeom prst="rect">
@@ -11803,14 +11836,220 @@
                 </a:solidFill>
                 <a:latin typeface="Calibri"/>
               </a:rPr>
-              <a:t>DEFINITIONS USED ABOVE</a:t>
+              <a:t>LIGHT SOURCES</a:t>
+            </a:r>
+          </a:p>
+        </p:txBody>
+      </p:sp>
+      <p:sp>
+        <p:nvSpPr>
+          <p:cNvPr id="39" name="TextBox 38"/>
+          <p:cNvSpPr txBox="1"/>
+          <p:nvPr/>
+        </p:nvSpPr>
+        <p:spPr>
+          <a:xfrm>
+            <a:off x="7452360" y="2697480"/>
+            <a:ext cx="4114800" cy="365760"/>
+          </a:xfrm>
+          <a:prstGeom prst="rect">
+            <a:avLst/>
+          </a:prstGeom>
+          <a:noFill/>
+        </p:spPr>
+        <p:txBody>
+          <a:bodyPr wrap="square" lIns="36576" rIns="36576" tIns="18288" bIns="18288" anchor="t">
+            <a:spAutoFit/>
+          </a:bodyPr>
+          <a:lstStyle/>
+          <a:p>
+            <a:pPr algn="l">
+              <a:lnSpc>
+                <a:spcPct val="100000"/>
+              </a:lnSpc>
+              <a:spcAft>
+                <a:spcPts val="400"/>
+              </a:spcAft>
+            </a:pPr>
+            <a:r>
+              <a:rPr sz="1300" b="0" i="0">
+                <a:solidFill>
+                  <a:srgbClr val="64748B"/>
+                </a:solidFill>
+                <a:latin typeface="Calibri"/>
+              </a:rPr>
+              <a:t>Directional · Point · Spot · Area (4×4 samples)</a:t>
             </a:r>
           </a:p>
         </p:txBody>
       </p:sp>
       <p:pic>
         <p:nvPicPr>
-          <p:cNvPr id="40" name="Picture 39" descr="defs.png"/>
+          <p:cNvPr id="40" name="Picture 39" descr="att.png"/>
+          <p:cNvPicPr>
+            <a:picLocks noChangeAspect="1"/>
+          </p:cNvPicPr>
+          <p:nvPr/>
+        </p:nvPicPr>
+        <p:blipFill>
+          <a:blip r:embed="rId11"/>
+          <a:stretch>
+            <a:fillRect/>
+          </a:stretch>
+        </p:blipFill>
+        <p:spPr>
+          <a:xfrm>
+            <a:off x="7976516" y="3017520"/>
+            <a:ext cx="2975046" cy="868680"/>
+          </a:xfrm>
+          <a:prstGeom prst="rect">
+            <a:avLst/>
+          </a:prstGeom>
+        </p:spPr>
+      </p:pic>
+      <p:sp>
+        <p:nvSpPr>
+          <p:cNvPr id="41" name="Rounded Rectangle 40"/>
+          <p:cNvSpPr/>
+          <p:nvPr/>
+        </p:nvSpPr>
+        <p:spPr>
+          <a:xfrm>
+            <a:off x="7223760" y="4069080"/>
+            <a:ext cx="4480560" cy="2286000"/>
+          </a:xfrm>
+          <a:prstGeom prst="roundRect">
+            <a:avLst>
+              <a:gd name="adj" fmla="val 4000"/>
+            </a:avLst>
+          </a:prstGeom>
+          <a:solidFill>
+            <a:srgbClr val="FFFFFF"/>
+          </a:solidFill>
+          <a:ln w="9525">
+            <a:solidFill>
+              <a:srgbClr val="DDE5EE"/>
+            </a:solidFill>
+          </a:ln>
+          <a:effectLst>
+            <a:outerShdw blurRad="114300" dist="25400" dir="5400000" algn="t" rotWithShape="0">
+              <a:srgbClr val="0B1220">
+                <a:alpha val="16000"/>
+              </a:srgbClr>
+            </a:outerShdw>
+          </a:effectLst>
+        </p:spPr>
+        <p:style>
+          <a:lnRef idx="1">
+            <a:schemeClr val="accent1"/>
+          </a:lnRef>
+          <a:fillRef idx="3">
+            <a:schemeClr val="accent1"/>
+          </a:fillRef>
+          <a:effectRef idx="2">
+            <a:schemeClr val="accent1"/>
+          </a:effectRef>
+          <a:fontRef idx="minor">
+            <a:schemeClr val="lt1"/>
+          </a:fontRef>
+        </p:style>
+        <p:txBody>
+          <a:bodyPr rtlCol="0" anchor="ctr"/>
+          <a:lstStyle/>
+          <a:p>
+            <a:pPr algn="ctr"/>
+          </a:p>
+        </p:txBody>
+      </p:sp>
+      <p:sp>
+        <p:nvSpPr>
+          <p:cNvPr id="42" name="Rectangle 41"/>
+          <p:cNvSpPr/>
+          <p:nvPr/>
+        </p:nvSpPr>
+        <p:spPr>
+          <a:xfrm>
+            <a:off x="7223760" y="4178808"/>
+            <a:ext cx="64008" cy="2066543"/>
+          </a:xfrm>
+          <a:prstGeom prst="rect">
+            <a:avLst/>
+          </a:prstGeom>
+          <a:solidFill>
+            <a:srgbClr val="0F8F85"/>
+          </a:solidFill>
+          <a:ln>
+            <a:noFill/>
+          </a:ln>
+          <a:effectLst/>
+        </p:spPr>
+        <p:style>
+          <a:lnRef idx="1">
+            <a:schemeClr val="accent1"/>
+          </a:lnRef>
+          <a:fillRef idx="3">
+            <a:schemeClr val="accent1"/>
+          </a:fillRef>
+          <a:effectRef idx="2">
+            <a:schemeClr val="accent1"/>
+          </a:effectRef>
+          <a:fontRef idx="minor">
+            <a:schemeClr val="lt1"/>
+          </a:fontRef>
+        </p:style>
+        <p:txBody>
+          <a:bodyPr rtlCol="0" anchor="ctr"/>
+          <a:lstStyle/>
+          <a:p>
+            <a:pPr algn="ctr"/>
+          </a:p>
+        </p:txBody>
+      </p:sp>
+      <p:sp>
+        <p:nvSpPr>
+          <p:cNvPr id="43" name="TextBox 42"/>
+          <p:cNvSpPr txBox="1"/>
+          <p:nvPr/>
+        </p:nvSpPr>
+        <p:spPr>
+          <a:xfrm>
+            <a:off x="7452360" y="4160520"/>
+            <a:ext cx="4114800" cy="347472"/>
+          </a:xfrm>
+          <a:prstGeom prst="rect">
+            <a:avLst/>
+          </a:prstGeom>
+          <a:noFill/>
+        </p:spPr>
+        <p:txBody>
+          <a:bodyPr wrap="square" lIns="36576" rIns="36576" tIns="18288" bIns="18288" anchor="t">
+            <a:spAutoFit/>
+          </a:bodyPr>
+          <a:lstStyle/>
+          <a:p>
+            <a:pPr algn="l">
+              <a:lnSpc>
+                <a:spcPct val="100000"/>
+              </a:lnSpc>
+              <a:spcAft>
+                <a:spcPts val="400"/>
+              </a:spcAft>
+            </a:pPr>
+            <a:r>
+              <a:rPr sz="1200" b="1" i="0">
+                <a:solidFill>
+                  <a:srgbClr val="0F8F85"/>
+                </a:solidFill>
+                <a:latin typeface="Calibri"/>
+              </a:rPr>
+              <a:t>DEFINITIONS USED ABOVE</a:t>
+            </a:r>
+          </a:p>
+        </p:txBody>
+      </p:sp>
+      <p:pic>
+        <p:nvPicPr>
+          <p:cNvPr id="44" name="Picture 43" descr="defs.png"/>
           <p:cNvPicPr>
             <a:picLocks noChangeAspect="1"/>
           </p:cNvPicPr>
@@ -11824,7 +12063,7 @@
         </p:blipFill>
         <p:spPr>
           <a:xfrm>
-            <a:off x="7543800" y="4740606"/>
+            <a:off x="7543800" y="4717746"/>
             <a:ext cx="3840480" cy="831154"/>
           </a:xfrm>
           <a:prstGeom prst="rect">
@@ -11834,7 +12073,7 @@
       </p:pic>
       <p:pic>
         <p:nvPicPr>
-          <p:cNvPr id="41" name="Picture 40" descr="ctdefs.png"/>
+          <p:cNvPr id="45" name="Picture 44" descr="ctdefs.png"/>
           <p:cNvPicPr>
             <a:picLocks noChangeAspect="1"/>
           </p:cNvPicPr>
@@ -11848,7 +12087,7 @@
         </p:blipFill>
         <p:spPr>
           <a:xfrm>
-            <a:off x="7543800" y="5681488"/>
+            <a:off x="7543800" y="5658628"/>
             <a:ext cx="3840480" cy="349536"/>
           </a:xfrm>
           <a:prstGeom prst="rect">
@@ -13108,7 +13347,7 @@
                 </a:solidFill>
                 <a:latin typeface="Calibri"/>
               </a:rPr>
-              <a:t>CASCADED SHADOW MAPS  (Λ = 0.75, N = 3, N = 0.1 M, R = 100 M)</a:t>
+              <a:t>CASCADED SHADOW MAPS</a:t>
             </a:r>
           </a:p>
         </p:txBody>
@@ -13129,7 +13368,7 @@
         </p:blipFill>
         <p:spPr>
           <a:xfrm>
-            <a:off x="868680" y="3358920"/>
+            <a:off x="868680" y="3345204"/>
             <a:ext cx="5669280" cy="597359"/>
           </a:xfrm>
           <a:prstGeom prst="rect">
@@ -13145,8 +13384,8 @@
         </p:nvSpPr>
         <p:spPr>
           <a:xfrm>
-            <a:off x="777240" y="4014215"/>
-            <a:ext cx="5943600" cy="566928"/>
+            <a:off x="777240" y="4105656"/>
+            <a:ext cx="5943600" cy="493776"/>
           </a:xfrm>
           <a:prstGeom prst="rect">
             <a:avLst/>
@@ -13154,7 +13393,7 @@
           <a:noFill/>
         </p:spPr>
         <p:txBody>
-          <a:bodyPr wrap="square" lIns="36576" rIns="36576" tIns="18288" bIns="18288" anchor="ctr">
+          <a:bodyPr wrap="square" lIns="36576" rIns="36576" tIns="18288" bIns="18288" anchor="b">
             <a:spAutoFit/>
           </a:bodyPr>
           <a:lstStyle/>
@@ -13164,17 +13403,36 @@
                 <a:spcPct val="100000"/>
               </a:lnSpc>
               <a:spcAft>
-                <a:spcPts val="100"/>
-              </a:spcAft>
-            </a:pPr>
-            <a:r>
-              <a:rPr sz="1300" b="0" i="0">
+                <a:spcPts val="0"/>
+              </a:spcAft>
+            </a:pPr>
+            <a:r>
+              <a:rPr sz="1200" b="0" i="0">
                 <a:solidFill>
                   <a:srgbClr val="64748B"/>
                 </a:solidFill>
                 <a:latin typeface="Calibri"/>
               </a:rPr>
-              <a:t>Cuts at 9.1, 24.2, 100 m · normal-offset lookup · 8 rotated PCF taps</a:t>
+              <a:t>λ = 0.75, N = 3, n = 0.1 m, r = 100 m  →  cuts at 9.1, 24.2, 100 m</a:t>
+            </a:r>
+          </a:p>
+          <a:p>
+            <a:pPr algn="l">
+              <a:lnSpc>
+                <a:spcPct val="100000"/>
+              </a:lnSpc>
+              <a:spcAft>
+                <a:spcPts val="0"/>
+              </a:spcAft>
+            </a:pPr>
+            <a:r>
+              <a:rPr sz="1200" b="0" i="0">
+                <a:solidFill>
+                  <a:srgbClr val="64748B"/>
+                </a:solidFill>
+                <a:latin typeface="Calibri"/>
+              </a:rPr>
+              <a:t>normal-offset lookup · 8 rotated percentage-closer taps</a:t>
             </a:r>
           </a:p>
         </p:txBody>
@@ -13335,7 +13593,7 @@
         </p:blipFill>
         <p:spPr>
           <a:xfrm>
-            <a:off x="918171" y="5217858"/>
+            <a:off x="918171" y="5194998"/>
             <a:ext cx="5570296" cy="384733"/>
           </a:xfrm>
           <a:prstGeom prst="rect">
@@ -13359,7 +13617,7 @@
         </p:blipFill>
         <p:spPr>
           <a:xfrm>
-            <a:off x="868680" y="5694032"/>
+            <a:off x="868680" y="5671172"/>
             <a:ext cx="5669280" cy="545541"/>
           </a:xfrm>
           <a:prstGeom prst="rect">

</xml_diff>

<commit_message>
Report and slides: compound, map, window and sound polish; updated check counts
</commit_message>
<xml_diff>
--- a/Docs/Deliverables/Slides/Sentinel_Presentation.pptx
+++ b/Docs/Deliverables/Slides/Sentinel_Presentation.pptx
@@ -14420,7 +14420,7 @@
                           </a:solidFill>
                           <a:latin typeface="Calibri"/>
                         </a:rPr>
-                        <a:t>GpuCheck</a:t>
+                        <a:t>Gpu, Window, Audio checks</a:t>
                       </a:r>
                     </a:p>
                   </a:txBody>
@@ -14443,7 +14443,7 @@
                           </a:solidFill>
                           <a:latin typeface="Calibri"/>
                         </a:rPr>
-                        <a:t>30</a:t>
+                        <a:t>30, 141, 79</a:t>
                       </a:r>
                     </a:p>
                   </a:txBody>

</xml_diff>

<commit_message>
Final update: roadmap counts, decisions, benchmark figures, code size and regenerated deliverables
</commit_message>
<xml_diff>
--- a/Docs/Deliverables/Slides/Sentinel_Presentation.pptx
+++ b/Docs/Deliverables/Slides/Sentinel_Presentation.pptx
@@ -200,19 +200,19 @@
                   <c:v>0.02</c:v>
                 </c:pt>
                 <c:pt idx="1">
-                  <c:v>1.21</c:v>
+                  <c:v>1.28</c:v>
                 </c:pt>
                 <c:pt idx="2">
-                  <c:v>1.2</c:v>
+                  <c:v>1.23</c:v>
                 </c:pt>
                 <c:pt idx="3">
-                  <c:v>1.58</c:v>
+                  <c:v>1.56</c:v>
                 </c:pt>
                 <c:pt idx="4">
-                  <c:v>2.79</c:v>
+                  <c:v>2.76</c:v>
                 </c:pt>
                 <c:pt idx="5">
-                  <c:v>4.11</c:v>
+                  <c:v>4.43</c:v>
                 </c:pt>
               </c:numCache>
             </c:numRef>
@@ -14178,7 +14178,7 @@
                 </a:solidFill>
                 <a:latin typeface="Calibri"/>
               </a:rPr>
-              <a:t>10.9 ms</a:t>
+              <a:t>11.3 ms</a:t>
             </a:r>
             <a:r>
               <a:rPr sz="1900" b="0" i="0">

</xml_diff>